<commit_message>
Deploy 2026-10-11 15:36:36 UTC
</commit_message>
<xml_diff>
--- a/assets/data/slides/Woche 4.pptx
+++ b/assets/data/slides/Woche 4.pptx
@@ -5,45 +5,44 @@
     <p:sldMasterId id="2147483648" r:id="rId1"/>
   </p:sldMasterIdLst>
   <p:notesMasterIdLst>
-    <p:notesMasterId r:id="rId35"/>
+    <p:notesMasterId r:id="rId34"/>
   </p:notesMasterIdLst>
   <p:handoutMasterIdLst>
-    <p:handoutMasterId r:id="rId36"/>
+    <p:handoutMasterId r:id="rId35"/>
   </p:handoutMasterIdLst>
   <p:sldIdLst>
     <p:sldId id="256" r:id="rId2"/>
     <p:sldId id="261" r:id="rId3"/>
-    <p:sldId id="292" r:id="rId4"/>
-    <p:sldId id="302" r:id="rId5"/>
-    <p:sldId id="310" r:id="rId6"/>
-    <p:sldId id="291" r:id="rId7"/>
-    <p:sldId id="311" r:id="rId8"/>
-    <p:sldId id="314" r:id="rId9"/>
-    <p:sldId id="312" r:id="rId10"/>
-    <p:sldId id="315" r:id="rId11"/>
-    <p:sldId id="316" r:id="rId12"/>
-    <p:sldId id="319" r:id="rId13"/>
-    <p:sldId id="318" r:id="rId14"/>
-    <p:sldId id="317" r:id="rId15"/>
-    <p:sldId id="320" r:id="rId16"/>
-    <p:sldId id="321" r:id="rId17"/>
-    <p:sldId id="322" r:id="rId18"/>
-    <p:sldId id="326" r:id="rId19"/>
-    <p:sldId id="323" r:id="rId20"/>
-    <p:sldId id="324" r:id="rId21"/>
-    <p:sldId id="325" r:id="rId22"/>
-    <p:sldId id="337" r:id="rId23"/>
-    <p:sldId id="327" r:id="rId24"/>
-    <p:sldId id="328" r:id="rId25"/>
-    <p:sldId id="331" r:id="rId26"/>
-    <p:sldId id="332" r:id="rId27"/>
-    <p:sldId id="329" r:id="rId28"/>
-    <p:sldId id="330" r:id="rId29"/>
-    <p:sldId id="333" r:id="rId30"/>
-    <p:sldId id="334" r:id="rId31"/>
-    <p:sldId id="335" r:id="rId32"/>
-    <p:sldId id="336" r:id="rId33"/>
-    <p:sldId id="309" r:id="rId34"/>
+    <p:sldId id="310" r:id="rId4"/>
+    <p:sldId id="291" r:id="rId5"/>
+    <p:sldId id="311" r:id="rId6"/>
+    <p:sldId id="314" r:id="rId7"/>
+    <p:sldId id="338" r:id="rId8"/>
+    <p:sldId id="312" r:id="rId9"/>
+    <p:sldId id="315" r:id="rId10"/>
+    <p:sldId id="316" r:id="rId11"/>
+    <p:sldId id="319" r:id="rId12"/>
+    <p:sldId id="318" r:id="rId13"/>
+    <p:sldId id="317" r:id="rId14"/>
+    <p:sldId id="320" r:id="rId15"/>
+    <p:sldId id="321" r:id="rId16"/>
+    <p:sldId id="322" r:id="rId17"/>
+    <p:sldId id="326" r:id="rId18"/>
+    <p:sldId id="323" r:id="rId19"/>
+    <p:sldId id="324" r:id="rId20"/>
+    <p:sldId id="325" r:id="rId21"/>
+    <p:sldId id="337" r:id="rId22"/>
+    <p:sldId id="327" r:id="rId23"/>
+    <p:sldId id="328" r:id="rId24"/>
+    <p:sldId id="331" r:id="rId25"/>
+    <p:sldId id="332" r:id="rId26"/>
+    <p:sldId id="329" r:id="rId27"/>
+    <p:sldId id="330" r:id="rId28"/>
+    <p:sldId id="333" r:id="rId29"/>
+    <p:sldId id="334" r:id="rId30"/>
+    <p:sldId id="335" r:id="rId31"/>
+    <p:sldId id="336" r:id="rId32"/>
+    <p:sldId id="309" r:id="rId33"/>
   </p:sldIdLst>
   <p:sldSz cx="12192000" cy="6858000"/>
   <p:notesSz cx="6858000" cy="9144000"/>
@@ -258,7 +257,7 @@
           <a:p>
             <a:fld id="{F68ABEA4-9216-4FDF-AAE1-D8632908A8EC}" type="datetimeFigureOut">
               <a:rPr lang="de-CH" smtClean="0"/>
-              <a:t>10.10.2026</a:t>
+              <a:t>11.10.2026</a:t>
             </a:fld>
             <a:endParaRPr lang="de-CH"/>
           </a:p>
@@ -435,7 +434,7 @@
           <a:p>
             <a:fld id="{4B78A90D-FE7E-41AF-B03D-808D82937CB9}" type="datetimeFigureOut">
               <a:rPr lang="de-CH" smtClean="0"/>
-              <a:t>10.10.2026</a:t>
+              <a:t>11.10.2026</a:t>
             </a:fld>
             <a:endParaRPr lang="de-CH"/>
           </a:p>
@@ -1163,7 +1162,7 @@
           <a:p>
             <a:fld id="{C47C2547-0B26-4181-9958-0F74634B97A1}" type="datetime1">
               <a:rPr lang="de-CH" noProof="0" smtClean="0"/>
-              <a:t>10.10.2026</a:t>
+              <a:t>11.10.2026</a:t>
             </a:fld>
             <a:endParaRPr lang="de-CH" noProof="0"/>
           </a:p>
@@ -1358,7 +1357,7 @@
           <a:p>
             <a:fld id="{4A533879-9C0F-4F94-919F-30B833E8871A}" type="datetime1">
               <a:rPr lang="de-CH" noProof="0" smtClean="0"/>
-              <a:t>10.10.2026</a:t>
+              <a:t>11.10.2026</a:t>
             </a:fld>
             <a:endParaRPr lang="de-CH" noProof="0"/>
           </a:p>
@@ -1645,7 +1644,7 @@
           <a:p>
             <a:fld id="{68EF82BE-DF56-4719-B180-C3B0D509F71F}" type="datetime1">
               <a:rPr lang="de-CH" noProof="0" smtClean="0"/>
-              <a:t>10.10.2026</a:t>
+              <a:t>11.10.2026</a:t>
             </a:fld>
             <a:endParaRPr lang="de-CH" noProof="0"/>
           </a:p>
@@ -1943,7 +1942,7 @@
           <a:p>
             <a:fld id="{3E1B9425-7348-43E2-B0E9-6A2A48F5FA8A}" type="datetime1">
               <a:rPr lang="de-CH" noProof="0" smtClean="0"/>
-              <a:t>10.10.2026</a:t>
+              <a:t>11.10.2026</a:t>
             </a:fld>
             <a:endParaRPr lang="de-CH" noProof="0"/>
           </a:p>
@@ -2343,7 +2342,7 @@
           <a:p>
             <a:fld id="{0F7782B2-018B-4FD3-AD95-2F64EDE0E9D6}" type="datetime1">
               <a:rPr lang="de-CH" noProof="0" smtClean="0"/>
-              <a:t>10.10.2026</a:t>
+              <a:t>11.10.2026</a:t>
             </a:fld>
             <a:endParaRPr lang="de-CH" noProof="0"/>
           </a:p>
@@ -2711,7 +2710,7 @@
           <a:p>
             <a:fld id="{D0A0FED0-443D-411A-B8E4-0668A8890EE3}" type="datetime1">
               <a:rPr lang="de-CH" noProof="0" smtClean="0"/>
-              <a:t>10.10.2026</a:t>
+              <a:t>11.10.2026</a:t>
             </a:fld>
             <a:endParaRPr lang="de-CH" noProof="0"/>
           </a:p>
@@ -4740,7 +4739,7 @@
           <a:p>
             <a:fld id="{1332D50A-E6CC-4D88-8908-F2129032F4C7}" type="datetime1">
               <a:rPr lang="de-CH" noProof="0" smtClean="0"/>
-              <a:t>10.10.2026</a:t>
+              <a:t>11.10.2026</a:t>
             </a:fld>
             <a:endParaRPr lang="de-CH" noProof="0"/>
           </a:p>
@@ -4987,7 +4986,7 @@
           <a:p>
             <a:fld id="{11B96697-4585-4368-989A-16003D150648}" type="datetime1">
               <a:rPr lang="de-CH" noProof="0" smtClean="0"/>
-              <a:t>10.10.2026</a:t>
+              <a:t>11.10.2026</a:t>
             </a:fld>
             <a:endParaRPr lang="de-CH" noProof="0"/>
           </a:p>
@@ -5235,7 +5234,7 @@
           <a:p>
             <a:fld id="{3A01E762-278A-4155-9BEB-7C2CB2386E92}" type="datetime1">
               <a:rPr lang="de-CH" noProof="0" smtClean="0"/>
-              <a:t>10.10.2026</a:t>
+              <a:t>11.10.2026</a:t>
             </a:fld>
             <a:endParaRPr lang="de-CH" noProof="0"/>
           </a:p>
@@ -5511,7 +5510,7 @@
           <a:p>
             <a:fld id="{6C4EAFE7-317E-4912-B75C-DD6945F82242}" type="datetime1">
               <a:rPr lang="de-CH" noProof="0" smtClean="0"/>
-              <a:t>10.10.2026</a:t>
+              <a:t>11.10.2026</a:t>
             </a:fld>
             <a:endParaRPr lang="de-CH" noProof="0"/>
           </a:p>
@@ -7442,7 +7441,7 @@
           <a:p>
             <a:fld id="{4A358CF3-A22A-46C1-A4E5-5810212466EF}" type="datetime1">
               <a:rPr lang="de-CH" noProof="0" smtClean="0"/>
-              <a:t>10.10.2026</a:t>
+              <a:t>11.10.2026</a:t>
             </a:fld>
             <a:endParaRPr lang="de-CH" noProof="0"/>
           </a:p>
@@ -8106,165 +8105,6 @@
           <p:cNvPr id="2" name="Title 1">
             <a:extLst>
               <a:ext uri="{FF2B5EF4-FFF2-40B4-BE49-F238E27FC236}">
-                <a16:creationId xmlns:a16="http://schemas.microsoft.com/office/drawing/2014/main" id="{E441C180-196E-F0AC-C7CD-BFFD16421107}"/>
-              </a:ext>
-            </a:extLst>
-          </p:cNvPr>
-          <p:cNvSpPr>
-            <a:spLocks noGrp="1"/>
-          </p:cNvSpPr>
-          <p:nvPr>
-            <p:ph type="title"/>
-          </p:nvPr>
-        </p:nvSpPr>
-        <p:spPr/>
-        <p:txBody>
-          <a:bodyPr/>
-          <a:lstStyle/>
-          <a:p>
-            <a:r>
-              <a:rPr lang="en-US" dirty="0" err="1"/>
-              <a:t>Stückweise</a:t>
-            </a:r>
-            <a:r>
-              <a:rPr lang="en-US" dirty="0"/>
-              <a:t> </a:t>
-            </a:r>
-            <a:r>
-              <a:rPr lang="en-US" dirty="0" err="1"/>
-              <a:t>Polynomiale</a:t>
-            </a:r>
-            <a:r>
-              <a:rPr lang="en-US" dirty="0"/>
-              <a:t> Interpolation</a:t>
-            </a:r>
-            <a:endParaRPr lang="en-CH" dirty="0"/>
-          </a:p>
-        </p:txBody>
-      </p:sp>
-      <p:sp>
-        <p:nvSpPr>
-          <p:cNvPr id="3" name="Date Placeholder 2">
-            <a:extLst>
-              <a:ext uri="{FF2B5EF4-FFF2-40B4-BE49-F238E27FC236}">
-                <a16:creationId xmlns:a16="http://schemas.microsoft.com/office/drawing/2014/main" id="{CA9B37DA-7967-CCB3-7779-323F6FB7FC38}"/>
-              </a:ext>
-            </a:extLst>
-          </p:cNvPr>
-          <p:cNvSpPr>
-            <a:spLocks noGrp="1"/>
-          </p:cNvSpPr>
-          <p:nvPr>
-            <p:ph type="dt" sz="half" idx="10"/>
-          </p:nvPr>
-        </p:nvSpPr>
-        <p:spPr/>
-        <p:txBody>
-          <a:bodyPr/>
-          <a:lstStyle/>
-          <a:p>
-            <a:fld id="{6C4EAFE7-317E-4912-B75C-DD6945F82242}" type="datetime1">
-              <a:rPr lang="de-CH" noProof="0" smtClean="0"/>
-              <a:t>10.10.2026</a:t>
-            </a:fld>
-            <a:endParaRPr lang="de-CH" noProof="0"/>
-          </a:p>
-        </p:txBody>
-      </p:sp>
-      <p:sp>
-        <p:nvSpPr>
-          <p:cNvPr id="4" name="Footer Placeholder 3">
-            <a:extLst>
-              <a:ext uri="{FF2B5EF4-FFF2-40B4-BE49-F238E27FC236}">
-                <a16:creationId xmlns:a16="http://schemas.microsoft.com/office/drawing/2014/main" id="{B88E9833-4A02-0662-CB34-0EE7A0EC8989}"/>
-              </a:ext>
-            </a:extLst>
-          </p:cNvPr>
-          <p:cNvSpPr>
-            <a:spLocks noGrp="1"/>
-          </p:cNvSpPr>
-          <p:nvPr>
-            <p:ph type="ftr" sz="quarter" idx="11"/>
-          </p:nvPr>
-        </p:nvSpPr>
-        <p:spPr/>
-        <p:txBody>
-          <a:bodyPr/>
-          <a:lstStyle/>
-          <a:p>
-            <a:r>
-              <a:rPr lang="de-DE"/>
-              <a:t>Department Informatik</a:t>
-            </a:r>
-            <a:endParaRPr lang="de-CH" noProof="0" dirty="0"/>
-          </a:p>
-        </p:txBody>
-      </p:sp>
-      <p:sp>
-        <p:nvSpPr>
-          <p:cNvPr id="5" name="Slide Number Placeholder 4">
-            <a:extLst>
-              <a:ext uri="{FF2B5EF4-FFF2-40B4-BE49-F238E27FC236}">
-                <a16:creationId xmlns:a16="http://schemas.microsoft.com/office/drawing/2014/main" id="{0A0529C1-84CB-D744-A582-E2D00B467A2B}"/>
-              </a:ext>
-            </a:extLst>
-          </p:cNvPr>
-          <p:cNvSpPr>
-            <a:spLocks noGrp="1"/>
-          </p:cNvSpPr>
-          <p:nvPr>
-            <p:ph type="sldNum" sz="quarter" idx="12"/>
-          </p:nvPr>
-        </p:nvSpPr>
-        <p:spPr/>
-        <p:txBody>
-          <a:bodyPr/>
-          <a:lstStyle/>
-          <a:p>
-            <a:fld id="{5ACA52AF-F19D-405C-AD5F-7D94B96A5CC3}" type="slidenum">
-              <a:rPr lang="de-CH" noProof="0" smtClean="0"/>
-              <a:pPr/>
-              <a:t>10</a:t>
-            </a:fld>
-            <a:endParaRPr lang="de-CH" noProof="0"/>
-          </a:p>
-        </p:txBody>
-      </p:sp>
-    </p:spTree>
-    <p:extLst>
-      <p:ext uri="{BB962C8B-B14F-4D97-AF65-F5344CB8AC3E}">
-        <p14:creationId xmlns:p14="http://schemas.microsoft.com/office/powerpoint/2010/main" val="1938745952"/>
-      </p:ext>
-    </p:extLst>
-  </p:cSld>
-  <p:clrMapOvr>
-    <a:masterClrMapping/>
-  </p:clrMapOvr>
-</p:sld>
-</file>
-
-<file path=ppt/slides/slide11.xml><?xml version="1.0" encoding="utf-8"?>
-<p:sld xmlns:a="http://schemas.openxmlformats.org/drawingml/2006/main" xmlns:r="http://schemas.openxmlformats.org/officeDocument/2006/relationships" xmlns:p="http://schemas.openxmlformats.org/presentationml/2006/main">
-  <p:cSld>
-    <p:spTree>
-      <p:nvGrpSpPr>
-        <p:cNvPr id="1" name=""/>
-        <p:cNvGrpSpPr/>
-        <p:nvPr/>
-      </p:nvGrpSpPr>
-      <p:grpSpPr>
-        <a:xfrm>
-          <a:off x="0" y="0"/>
-          <a:ext cx="0" cy="0"/>
-          <a:chOff x="0" y="0"/>
-          <a:chExt cx="0" cy="0"/>
-        </a:xfrm>
-      </p:grpSpPr>
-      <p:sp>
-        <p:nvSpPr>
-          <p:cNvPr id="2" name="Title 1">
-            <a:extLst>
-              <a:ext uri="{FF2B5EF4-FFF2-40B4-BE49-F238E27FC236}">
                 <a16:creationId xmlns:a16="http://schemas.microsoft.com/office/drawing/2014/main" id="{EB5E5104-CC55-D8A6-6359-B1B024209581}"/>
               </a:ext>
             </a:extLst>
@@ -8841,7 +8681,7 @@
           <a:p>
             <a:fld id="{11B96697-4585-4368-989A-16003D150648}" type="datetime1">
               <a:rPr lang="de-CH" noProof="0" smtClean="0"/>
-              <a:t>10.10.2026</a:t>
+              <a:t>11.10.2026</a:t>
             </a:fld>
             <a:endParaRPr lang="de-CH" noProof="0"/>
           </a:p>
@@ -8899,7 +8739,7 @@
           <a:p>
             <a:fld id="{5ACA52AF-F19D-405C-AD5F-7D94B96A5CC3}" type="slidenum">
               <a:rPr lang="de-CH" noProof="0" smtClean="0"/>
-              <a:t>11</a:t>
+              <a:t>10</a:t>
             </a:fld>
             <a:endParaRPr lang="de-CH" noProof="0"/>
           </a:p>
@@ -9059,7 +8899,7 @@
 </p:sld>
 </file>
 
-<file path=ppt/slides/slide12.xml><?xml version="1.0" encoding="utf-8"?>
+<file path=ppt/slides/slide11.xml><?xml version="1.0" encoding="utf-8"?>
 <p:sld xmlns:a="http://schemas.openxmlformats.org/drawingml/2006/main" xmlns:r="http://schemas.openxmlformats.org/officeDocument/2006/relationships" xmlns:p="http://schemas.openxmlformats.org/presentationml/2006/main">
   <p:cSld>
     <p:spTree>
@@ -9140,7 +8980,7 @@
           <a:p>
             <a:fld id="{11B96697-4585-4368-989A-16003D150648}" type="datetime1">
               <a:rPr lang="de-CH" noProof="0" smtClean="0"/>
-              <a:t>10.10.2026</a:t>
+              <a:t>11.10.2026</a:t>
             </a:fld>
             <a:endParaRPr lang="de-CH" noProof="0"/>
           </a:p>
@@ -9198,7 +9038,7 @@
           <a:p>
             <a:fld id="{5ACA52AF-F19D-405C-AD5F-7D94B96A5CC3}" type="slidenum">
               <a:rPr lang="de-CH" noProof="0" smtClean="0"/>
-              <a:t>12</a:t>
+              <a:t>11</a:t>
             </a:fld>
             <a:endParaRPr lang="de-CH" noProof="0"/>
           </a:p>
@@ -9249,7 +9089,7 @@
 </p:sld>
 </file>
 
-<file path=ppt/slides/slide13.xml><?xml version="1.0" encoding="utf-8"?>
+<file path=ppt/slides/slide12.xml><?xml version="1.0" encoding="utf-8"?>
 <p:sld xmlns:a="http://schemas.openxmlformats.org/drawingml/2006/main" xmlns:r="http://schemas.openxmlformats.org/officeDocument/2006/relationships" xmlns:p="http://schemas.openxmlformats.org/presentationml/2006/main">
   <p:cSld>
     <p:spTree>
@@ -9330,7 +9170,7 @@
           <a:p>
             <a:fld id="{6C4EAFE7-317E-4912-B75C-DD6945F82242}" type="datetime1">
               <a:rPr lang="de-CH" noProof="0" smtClean="0"/>
-              <a:t>10.10.2026</a:t>
+              <a:t>11.10.2026</a:t>
             </a:fld>
             <a:endParaRPr lang="de-CH" noProof="0"/>
           </a:p>
@@ -9389,7 +9229,7 @@
             <a:fld id="{5ACA52AF-F19D-405C-AD5F-7D94B96A5CC3}" type="slidenum">
               <a:rPr lang="de-CH" noProof="0" smtClean="0"/>
               <a:pPr/>
-              <a:t>13</a:t>
+              <a:t>12</a:t>
             </a:fld>
             <a:endParaRPr lang="de-CH" noProof="0"/>
           </a:p>
@@ -9408,7 +9248,7 @@
 </p:sld>
 </file>
 
-<file path=ppt/slides/slide14.xml><?xml version="1.0" encoding="utf-8"?>
+<file path=ppt/slides/slide13.xml><?xml version="1.0" encoding="utf-8"?>
 <p:sld xmlns:a="http://schemas.openxmlformats.org/drawingml/2006/main" xmlns:r="http://schemas.openxmlformats.org/officeDocument/2006/relationships" xmlns:p="http://schemas.openxmlformats.org/presentationml/2006/main">
   <p:cSld>
     <p:spTree>
@@ -9489,7 +9329,7 @@
           <a:p>
             <a:fld id="{11B96697-4585-4368-989A-16003D150648}" type="datetime1">
               <a:rPr lang="de-CH" noProof="0" smtClean="0"/>
-              <a:t>10.10.2026</a:t>
+              <a:t>11.10.2026</a:t>
             </a:fld>
             <a:endParaRPr lang="de-CH" noProof="0"/>
           </a:p>
@@ -9547,7 +9387,7 @@
           <a:p>
             <a:fld id="{5ACA52AF-F19D-405C-AD5F-7D94B96A5CC3}" type="slidenum">
               <a:rPr lang="de-CH" noProof="0" smtClean="0"/>
-              <a:t>14</a:t>
+              <a:t>13</a:t>
             </a:fld>
             <a:endParaRPr lang="de-CH" noProof="0"/>
           </a:p>
@@ -12324,7 +12164,7 @@
 </p:sld>
 </file>
 
-<file path=ppt/slides/slide15.xml><?xml version="1.0" encoding="utf-8"?>
+<file path=ppt/slides/slide14.xml><?xml version="1.0" encoding="utf-8"?>
 <p:sld xmlns:a="http://schemas.openxmlformats.org/drawingml/2006/main" xmlns:r="http://schemas.openxmlformats.org/officeDocument/2006/relationships" xmlns:p="http://schemas.openxmlformats.org/presentationml/2006/main">
   <p:cSld>
     <p:spTree>
@@ -12426,7 +12266,7 @@
                   <a:spcPts val="600"/>
                 </a:spcAft>
               </a:pPr>
-              <a:t>10.10.2026</a:t>
+              <a:t>11.10.2026</a:t>
             </a:fld>
             <a:endParaRPr lang="de-CH" noProof="0"/>
           </a:p>
@@ -12513,7 +12353,7 @@
                   <a:spcPts val="600"/>
                 </a:spcAft>
               </a:pPr>
-              <a:t>15</a:t>
+              <a:t>14</a:t>
             </a:fld>
             <a:endParaRPr lang="de-CH" noProof="0"/>
           </a:p>
@@ -13156,7 +12996,7 @@
 </p:sld>
 </file>
 
-<file path=ppt/slides/slide16.xml><?xml version="1.0" encoding="utf-8"?>
+<file path=ppt/slides/slide15.xml><?xml version="1.0" encoding="utf-8"?>
 <p:sld xmlns:a="http://schemas.openxmlformats.org/drawingml/2006/main" xmlns:r="http://schemas.openxmlformats.org/officeDocument/2006/relationships" xmlns:p="http://schemas.openxmlformats.org/presentationml/2006/main">
   <p:cSld>
     <p:spTree>
@@ -13225,7 +13065,7 @@
           <a:p>
             <a:fld id="{6C4EAFE7-317E-4912-B75C-DD6945F82242}" type="datetime1">
               <a:rPr lang="de-CH" noProof="0" smtClean="0"/>
-              <a:t>10.10.2026</a:t>
+              <a:t>11.10.2026</a:t>
             </a:fld>
             <a:endParaRPr lang="de-CH" noProof="0"/>
           </a:p>
@@ -13284,7 +13124,7 @@
             <a:fld id="{5ACA52AF-F19D-405C-AD5F-7D94B96A5CC3}" type="slidenum">
               <a:rPr lang="de-CH" noProof="0" smtClean="0"/>
               <a:pPr/>
-              <a:t>16</a:t>
+              <a:t>15</a:t>
             </a:fld>
             <a:endParaRPr lang="de-CH" noProof="0"/>
           </a:p>
@@ -13303,7 +13143,7 @@
 </p:sld>
 </file>
 
-<file path=ppt/slides/slide17.xml><?xml version="1.0" encoding="utf-8"?>
+<file path=ppt/slides/slide16.xml><?xml version="1.0" encoding="utf-8"?>
 <p:sld xmlns:a="http://schemas.openxmlformats.org/drawingml/2006/main" xmlns:r="http://schemas.openxmlformats.org/officeDocument/2006/relationships" xmlns:p="http://schemas.openxmlformats.org/presentationml/2006/main">
   <p:cSld>
     <p:spTree>
@@ -13957,7 +13797,7 @@
           <a:p>
             <a:fld id="{11B96697-4585-4368-989A-16003D150648}" type="datetime1">
               <a:rPr lang="de-CH" noProof="0" smtClean="0"/>
-              <a:t>10.10.2026</a:t>
+              <a:t>11.10.2026</a:t>
             </a:fld>
             <a:endParaRPr lang="de-CH" noProof="0"/>
           </a:p>
@@ -14015,7 +13855,7 @@
           <a:p>
             <a:fld id="{5ACA52AF-F19D-405C-AD5F-7D94B96A5CC3}" type="slidenum">
               <a:rPr lang="de-CH" noProof="0" smtClean="0"/>
-              <a:t>17</a:t>
+              <a:t>16</a:t>
             </a:fld>
             <a:endParaRPr lang="de-CH" noProof="0"/>
           </a:p>
@@ -14567,7 +14407,7 @@
 </p:sld>
 </file>
 
-<file path=ppt/slides/slide18.xml><?xml version="1.0" encoding="utf-8"?>
+<file path=ppt/slides/slide17.xml><?xml version="1.0" encoding="utf-8"?>
 <p:sld xmlns:a="http://schemas.openxmlformats.org/drawingml/2006/main" xmlns:r="http://schemas.openxmlformats.org/officeDocument/2006/relationships" xmlns:p="http://schemas.openxmlformats.org/presentationml/2006/main">
   <p:cSld>
     <p:spTree>
@@ -14636,7 +14476,7 @@
           <a:p>
             <a:fld id="{11B96697-4585-4368-989A-16003D150648}" type="datetime1">
               <a:rPr lang="de-CH" noProof="0" smtClean="0"/>
-              <a:t>10.10.2026</a:t>
+              <a:t>11.10.2026</a:t>
             </a:fld>
             <a:endParaRPr lang="de-CH" noProof="0"/>
           </a:p>
@@ -14694,7 +14534,7 @@
           <a:p>
             <a:fld id="{5ACA52AF-F19D-405C-AD5F-7D94B96A5CC3}" type="slidenum">
               <a:rPr lang="de-CH" noProof="0" smtClean="0"/>
-              <a:t>18</a:t>
+              <a:t>17</a:t>
             </a:fld>
             <a:endParaRPr lang="de-CH" noProof="0"/>
           </a:p>
@@ -14773,7 +14613,7 @@
 </p:sld>
 </file>
 
-<file path=ppt/slides/slide19.xml><?xml version="1.0" encoding="utf-8"?>
+<file path=ppt/slides/slide18.xml><?xml version="1.0" encoding="utf-8"?>
 <p:sld xmlns:a="http://schemas.openxmlformats.org/drawingml/2006/main" xmlns:r="http://schemas.openxmlformats.org/officeDocument/2006/relationships" xmlns:p="http://schemas.openxmlformats.org/presentationml/2006/main">
   <p:cSld>
     <p:spTree>
@@ -14823,8 +14663,8 @@
           </a:p>
         </p:txBody>
       </p:sp>
-      <mc:AlternateContent xmlns:mc="http://schemas.openxmlformats.org/markup-compatibility/2006">
-        <mc:Choice xmlns:a14="http://schemas.microsoft.com/office/drawing/2010/main" Requires="a14">
+      <mc:AlternateContent xmlns:mc="http://schemas.openxmlformats.org/markup-compatibility/2006" xmlns:a14="http://schemas.microsoft.com/office/drawing/2010/main">
+        <mc:Choice Requires="a14">
           <p:sp>
             <p:nvSpPr>
               <p:cNvPr id="3" name="Content Placeholder 2">
@@ -16324,7 +16164,7 @@
             </p:txBody>
           </p:sp>
         </mc:Choice>
-        <mc:Fallback>
+        <mc:Fallback xmlns="">
           <p:sp>
             <p:nvSpPr>
               <p:cNvPr id="3" name="Content Placeholder 2">
@@ -16387,7 +16227,7 @@
           <a:p>
             <a:fld id="{11B96697-4585-4368-989A-16003D150648}" type="datetime1">
               <a:rPr lang="de-CH" noProof="0" smtClean="0"/>
-              <a:t>10.10.2026</a:t>
+              <a:t>11.10.2026</a:t>
             </a:fld>
             <a:endParaRPr lang="de-CH" noProof="0"/>
           </a:p>
@@ -16445,7 +16285,7 @@
           <a:p>
             <a:fld id="{5ACA52AF-F19D-405C-AD5F-7D94B96A5CC3}" type="slidenum">
               <a:rPr lang="de-CH" noProof="0" smtClean="0"/>
-              <a:t>19</a:t>
+              <a:t>18</a:t>
             </a:fld>
             <a:endParaRPr lang="de-CH" noProof="0"/>
           </a:p>
@@ -16851,8 +16691,8 @@
             </p:sp>
           </mc:Fallback>
         </mc:AlternateContent>
-        <mc:AlternateContent xmlns:mc="http://schemas.openxmlformats.org/markup-compatibility/2006">
-          <mc:Choice xmlns:a14="http://schemas.microsoft.com/office/drawing/2010/main" Requires="a14">
+        <mc:AlternateContent xmlns:mc="http://schemas.openxmlformats.org/markup-compatibility/2006" xmlns:a14="http://schemas.microsoft.com/office/drawing/2010/main">
+          <mc:Choice Requires="a14">
             <p:sp>
               <p:nvSpPr>
                 <p:cNvPr id="10" name="TextBox 9">
@@ -17186,7 +17026,7 @@
               </p:txBody>
             </p:sp>
           </mc:Choice>
-          <mc:Fallback>
+          <mc:Fallback xmlns="">
             <p:sp>
               <p:nvSpPr>
                 <p:cNvPr id="10" name="TextBox 9">
@@ -17588,192 +17428,7 @@
 </p:sld>
 </file>
 
-<file path=ppt/slides/slide2.xml><?xml version="1.0" encoding="utf-8"?>
-<p:sld xmlns:a="http://schemas.openxmlformats.org/drawingml/2006/main" xmlns:r="http://schemas.openxmlformats.org/officeDocument/2006/relationships" xmlns:p="http://schemas.openxmlformats.org/presentationml/2006/main">
-  <p:cSld>
-    <p:spTree>
-      <p:nvGrpSpPr>
-        <p:cNvPr id="1" name=""/>
-        <p:cNvGrpSpPr/>
-        <p:nvPr/>
-      </p:nvGrpSpPr>
-      <p:grpSpPr>
-        <a:xfrm>
-          <a:off x="0" y="0"/>
-          <a:ext cx="0" cy="0"/>
-          <a:chOff x="0" y="0"/>
-          <a:chExt cx="0" cy="0"/>
-        </a:xfrm>
-      </p:grpSpPr>
-      <p:sp>
-        <p:nvSpPr>
-          <p:cNvPr id="2" name="Titel 1">
-            <a:extLst>
-              <a:ext uri="{FF2B5EF4-FFF2-40B4-BE49-F238E27FC236}">
-                <a16:creationId xmlns:a16="http://schemas.microsoft.com/office/drawing/2014/main" id="{6B050A74-6ED2-41B3-AD63-74F89C447FBB}"/>
-              </a:ext>
-            </a:extLst>
-          </p:cNvPr>
-          <p:cNvSpPr>
-            <a:spLocks noGrp="1"/>
-          </p:cNvSpPr>
-          <p:nvPr>
-            <p:ph type="title"/>
-          </p:nvPr>
-        </p:nvSpPr>
-        <p:spPr/>
-        <p:txBody>
-          <a:bodyPr/>
-          <a:lstStyle/>
-          <a:p>
-            <a:r>
-              <a:rPr lang="de-CH" dirty="0"/>
-              <a:t>Agenda</a:t>
-            </a:r>
-          </a:p>
-        </p:txBody>
-      </p:sp>
-      <p:sp>
-        <p:nvSpPr>
-          <p:cNvPr id="3" name="Inhaltsplatzhalter 2">
-            <a:extLst>
-              <a:ext uri="{FF2B5EF4-FFF2-40B4-BE49-F238E27FC236}">
-                <a16:creationId xmlns:a16="http://schemas.microsoft.com/office/drawing/2014/main" id="{94792F61-F3A1-4E2C-B0EE-9742603FD08B}"/>
-              </a:ext>
-            </a:extLst>
-          </p:cNvPr>
-          <p:cNvSpPr>
-            <a:spLocks noGrp="1"/>
-          </p:cNvSpPr>
-          <p:nvPr>
-            <p:ph idx="1"/>
-          </p:nvPr>
-        </p:nvSpPr>
-        <p:spPr/>
-        <p:txBody>
-          <a:bodyPr/>
-          <a:lstStyle/>
-          <a:p>
-            <a:r>
-              <a:rPr lang="de-DE" dirty="0"/>
-              <a:t>Recap</a:t>
-            </a:r>
-          </a:p>
-          <a:p>
-            <a:endParaRPr lang="de-DE" dirty="0"/>
-          </a:p>
-          <a:p>
-            <a:r>
-              <a:rPr lang="de-DE" dirty="0"/>
-              <a:t>Quiz review</a:t>
-            </a:r>
-          </a:p>
-          <a:p>
-            <a:endParaRPr lang="de-CH" dirty="0"/>
-          </a:p>
-        </p:txBody>
-      </p:sp>
-      <p:sp>
-        <p:nvSpPr>
-          <p:cNvPr id="5" name="Fußzeilenplatzhalter 4">
-            <a:extLst>
-              <a:ext uri="{FF2B5EF4-FFF2-40B4-BE49-F238E27FC236}">
-                <a16:creationId xmlns:a16="http://schemas.microsoft.com/office/drawing/2014/main" id="{4A08BFF2-5DEB-4FE4-A3E3-C18FD3A38B4D}"/>
-              </a:ext>
-            </a:extLst>
-          </p:cNvPr>
-          <p:cNvSpPr>
-            <a:spLocks noGrp="1"/>
-          </p:cNvSpPr>
-          <p:nvPr>
-            <p:ph type="ftr" sz="quarter" idx="11"/>
-          </p:nvPr>
-        </p:nvSpPr>
-        <p:spPr/>
-        <p:txBody>
-          <a:bodyPr/>
-          <a:lstStyle/>
-          <a:p>
-            <a:r>
-              <a:rPr lang="de-DE" dirty="0"/>
-              <a:t>Department Informatik</a:t>
-            </a:r>
-            <a:endParaRPr lang="de-CH" noProof="0" dirty="0"/>
-          </a:p>
-        </p:txBody>
-      </p:sp>
-      <p:sp>
-        <p:nvSpPr>
-          <p:cNvPr id="4" name="Datumsplatzhalter 3">
-            <a:extLst>
-              <a:ext uri="{FF2B5EF4-FFF2-40B4-BE49-F238E27FC236}">
-                <a16:creationId xmlns:a16="http://schemas.microsoft.com/office/drawing/2014/main" id="{FB726846-AD64-4677-BEA5-D3BDD96C70A4}"/>
-              </a:ext>
-            </a:extLst>
-          </p:cNvPr>
-          <p:cNvSpPr>
-            <a:spLocks noGrp="1"/>
-          </p:cNvSpPr>
-          <p:nvPr>
-            <p:ph type="dt" sz="half" idx="10"/>
-          </p:nvPr>
-        </p:nvSpPr>
-        <p:spPr/>
-        <p:txBody>
-          <a:bodyPr/>
-          <a:lstStyle/>
-          <a:p>
-            <a:fld id="{6BA2947E-D2DB-4F76-9588-775FC8D85F8C}" type="datetime1">
-              <a:rPr lang="de-CH" noProof="0" smtClean="0"/>
-              <a:t>10.10.2026</a:t>
-            </a:fld>
-            <a:endParaRPr lang="de-CH" noProof="0"/>
-          </a:p>
-        </p:txBody>
-      </p:sp>
-      <p:sp>
-        <p:nvSpPr>
-          <p:cNvPr id="6" name="Foliennummernplatzhalter 5">
-            <a:extLst>
-              <a:ext uri="{FF2B5EF4-FFF2-40B4-BE49-F238E27FC236}">
-                <a16:creationId xmlns:a16="http://schemas.microsoft.com/office/drawing/2014/main" id="{9D665EC3-3ED3-4D21-AC3C-EAD0881BA091}"/>
-              </a:ext>
-            </a:extLst>
-          </p:cNvPr>
-          <p:cNvSpPr>
-            <a:spLocks noGrp="1"/>
-          </p:cNvSpPr>
-          <p:nvPr>
-            <p:ph type="sldNum" sz="quarter" idx="12"/>
-          </p:nvPr>
-        </p:nvSpPr>
-        <p:spPr/>
-        <p:txBody>
-          <a:bodyPr/>
-          <a:lstStyle/>
-          <a:p>
-            <a:fld id="{5ACA52AF-F19D-405C-AD5F-7D94B96A5CC3}" type="slidenum">
-              <a:rPr lang="de-CH" noProof="0" smtClean="0"/>
-              <a:t>2</a:t>
-            </a:fld>
-            <a:endParaRPr lang="de-CH" noProof="0"/>
-          </a:p>
-        </p:txBody>
-      </p:sp>
-    </p:spTree>
-    <p:extLst>
-      <p:ext uri="{BB962C8B-B14F-4D97-AF65-F5344CB8AC3E}">
-        <p14:creationId xmlns:p14="http://schemas.microsoft.com/office/powerpoint/2010/main" val="3164086109"/>
-      </p:ext>
-    </p:extLst>
-  </p:cSld>
-  <p:clrMapOvr>
-    <a:masterClrMapping/>
-  </p:clrMapOvr>
-</p:sld>
-</file>
-
-<file path=ppt/slides/slide20.xml><?xml version="1.0" encoding="utf-8"?>
+<file path=ppt/slides/slide19.xml><?xml version="1.0" encoding="utf-8"?>
 <p:sld xmlns:a="http://schemas.openxmlformats.org/drawingml/2006/main" xmlns:r="http://schemas.openxmlformats.org/officeDocument/2006/relationships" xmlns:p="http://schemas.openxmlformats.org/presentationml/2006/main">
   <p:cSld>
     <p:spTree>
@@ -18795,7 +18450,7 @@
           <a:p>
             <a:fld id="{11B96697-4585-4368-989A-16003D150648}" type="datetime1">
               <a:rPr lang="de-CH" noProof="0" smtClean="0"/>
-              <a:t>10.10.2026</a:t>
+              <a:t>11.10.2026</a:t>
             </a:fld>
             <a:endParaRPr lang="de-CH" noProof="0"/>
           </a:p>
@@ -18853,7 +18508,7 @@
           <a:p>
             <a:fld id="{5ACA52AF-F19D-405C-AD5F-7D94B96A5CC3}" type="slidenum">
               <a:rPr lang="de-CH" noProof="0" smtClean="0"/>
-              <a:t>20</a:t>
+              <a:t>19</a:t>
             </a:fld>
             <a:endParaRPr lang="de-CH" noProof="0"/>
           </a:p>
@@ -18872,7 +18527,204 @@
 </p:sld>
 </file>
 
-<file path=ppt/slides/slide21.xml><?xml version="1.0" encoding="utf-8"?>
+<file path=ppt/slides/slide2.xml><?xml version="1.0" encoding="utf-8"?>
+<p:sld xmlns:a="http://schemas.openxmlformats.org/drawingml/2006/main" xmlns:r="http://schemas.openxmlformats.org/officeDocument/2006/relationships" xmlns:p="http://schemas.openxmlformats.org/presentationml/2006/main">
+  <p:cSld>
+    <p:spTree>
+      <p:nvGrpSpPr>
+        <p:cNvPr id="1" name=""/>
+        <p:cNvGrpSpPr/>
+        <p:nvPr/>
+      </p:nvGrpSpPr>
+      <p:grpSpPr>
+        <a:xfrm>
+          <a:off x="0" y="0"/>
+          <a:ext cx="0" cy="0"/>
+          <a:chOff x="0" y="0"/>
+          <a:chExt cx="0" cy="0"/>
+        </a:xfrm>
+      </p:grpSpPr>
+      <p:sp>
+        <p:nvSpPr>
+          <p:cNvPr id="2" name="Titel 1">
+            <a:extLst>
+              <a:ext uri="{FF2B5EF4-FFF2-40B4-BE49-F238E27FC236}">
+                <a16:creationId xmlns:a16="http://schemas.microsoft.com/office/drawing/2014/main" id="{6B050A74-6ED2-41B3-AD63-74F89C447FBB}"/>
+              </a:ext>
+            </a:extLst>
+          </p:cNvPr>
+          <p:cNvSpPr>
+            <a:spLocks noGrp="1"/>
+          </p:cNvSpPr>
+          <p:nvPr>
+            <p:ph type="title"/>
+          </p:nvPr>
+        </p:nvSpPr>
+        <p:spPr/>
+        <p:txBody>
+          <a:bodyPr/>
+          <a:lstStyle/>
+          <a:p>
+            <a:r>
+              <a:rPr lang="de-CH" dirty="0"/>
+              <a:t>Agenda</a:t>
+            </a:r>
+          </a:p>
+        </p:txBody>
+      </p:sp>
+      <p:sp>
+        <p:nvSpPr>
+          <p:cNvPr id="3" name="Inhaltsplatzhalter 2">
+            <a:extLst>
+              <a:ext uri="{FF2B5EF4-FFF2-40B4-BE49-F238E27FC236}">
+                <a16:creationId xmlns:a16="http://schemas.microsoft.com/office/drawing/2014/main" id="{94792F61-F3A1-4E2C-B0EE-9742603FD08B}"/>
+              </a:ext>
+            </a:extLst>
+          </p:cNvPr>
+          <p:cNvSpPr>
+            <a:spLocks noGrp="1"/>
+          </p:cNvSpPr>
+          <p:nvPr>
+            <p:ph idx="1"/>
+          </p:nvPr>
+        </p:nvSpPr>
+        <p:spPr/>
+        <p:txBody>
+          <a:bodyPr/>
+          <a:lstStyle/>
+          <a:p>
+            <a:r>
+              <a:rPr lang="de-CH" dirty="0"/>
+              <a:t>Chebyshev-Interpolation &amp; DCT</a:t>
+            </a:r>
+          </a:p>
+          <a:p>
+            <a:r>
+              <a:rPr lang="de-CH" dirty="0"/>
+              <a:t>Stückweise lineare Interpolation</a:t>
+            </a:r>
+          </a:p>
+          <a:p>
+            <a:r>
+              <a:rPr lang="de-CH" dirty="0"/>
+              <a:t>Kubisch Hermite Interpolation</a:t>
+            </a:r>
+          </a:p>
+          <a:p>
+            <a:r>
+              <a:rPr lang="de-CH" dirty="0"/>
+              <a:t>Kubische Splines</a:t>
+            </a:r>
+          </a:p>
+          <a:p>
+            <a:r>
+              <a:rPr lang="de-CH" dirty="0"/>
+              <a:t>Tafelbeispiel Quadratische Splines</a:t>
+            </a:r>
+          </a:p>
+        </p:txBody>
+      </p:sp>
+      <p:sp>
+        <p:nvSpPr>
+          <p:cNvPr id="5" name="Fußzeilenplatzhalter 4">
+            <a:extLst>
+              <a:ext uri="{FF2B5EF4-FFF2-40B4-BE49-F238E27FC236}">
+                <a16:creationId xmlns:a16="http://schemas.microsoft.com/office/drawing/2014/main" id="{4A08BFF2-5DEB-4FE4-A3E3-C18FD3A38B4D}"/>
+              </a:ext>
+            </a:extLst>
+          </p:cNvPr>
+          <p:cNvSpPr>
+            <a:spLocks noGrp="1"/>
+          </p:cNvSpPr>
+          <p:nvPr>
+            <p:ph type="ftr" sz="quarter" idx="11"/>
+          </p:nvPr>
+        </p:nvSpPr>
+        <p:spPr/>
+        <p:txBody>
+          <a:bodyPr/>
+          <a:lstStyle/>
+          <a:p>
+            <a:r>
+              <a:rPr lang="de-DE" dirty="0"/>
+              <a:t>Department Informatik</a:t>
+            </a:r>
+            <a:endParaRPr lang="de-CH" noProof="0" dirty="0"/>
+          </a:p>
+        </p:txBody>
+      </p:sp>
+      <p:sp>
+        <p:nvSpPr>
+          <p:cNvPr id="4" name="Datumsplatzhalter 3">
+            <a:extLst>
+              <a:ext uri="{FF2B5EF4-FFF2-40B4-BE49-F238E27FC236}">
+                <a16:creationId xmlns:a16="http://schemas.microsoft.com/office/drawing/2014/main" id="{FB726846-AD64-4677-BEA5-D3BDD96C70A4}"/>
+              </a:ext>
+            </a:extLst>
+          </p:cNvPr>
+          <p:cNvSpPr>
+            <a:spLocks noGrp="1"/>
+          </p:cNvSpPr>
+          <p:nvPr>
+            <p:ph type="dt" sz="half" idx="10"/>
+          </p:nvPr>
+        </p:nvSpPr>
+        <p:spPr/>
+        <p:txBody>
+          <a:bodyPr/>
+          <a:lstStyle/>
+          <a:p>
+            <a:fld id="{6BA2947E-D2DB-4F76-9588-775FC8D85F8C}" type="datetime1">
+              <a:rPr lang="de-CH" noProof="0" smtClean="0"/>
+              <a:t>11.10.2026</a:t>
+            </a:fld>
+            <a:endParaRPr lang="de-CH" noProof="0"/>
+          </a:p>
+        </p:txBody>
+      </p:sp>
+      <p:sp>
+        <p:nvSpPr>
+          <p:cNvPr id="6" name="Foliennummernplatzhalter 5">
+            <a:extLst>
+              <a:ext uri="{FF2B5EF4-FFF2-40B4-BE49-F238E27FC236}">
+                <a16:creationId xmlns:a16="http://schemas.microsoft.com/office/drawing/2014/main" id="{9D665EC3-3ED3-4D21-AC3C-EAD0881BA091}"/>
+              </a:ext>
+            </a:extLst>
+          </p:cNvPr>
+          <p:cNvSpPr>
+            <a:spLocks noGrp="1"/>
+          </p:cNvSpPr>
+          <p:nvPr>
+            <p:ph type="sldNum" sz="quarter" idx="12"/>
+          </p:nvPr>
+        </p:nvSpPr>
+        <p:spPr/>
+        <p:txBody>
+          <a:bodyPr/>
+          <a:lstStyle/>
+          <a:p>
+            <a:fld id="{5ACA52AF-F19D-405C-AD5F-7D94B96A5CC3}" type="slidenum">
+              <a:rPr lang="de-CH" noProof="0" smtClean="0"/>
+              <a:t>2</a:t>
+            </a:fld>
+            <a:endParaRPr lang="de-CH" noProof="0"/>
+          </a:p>
+        </p:txBody>
+      </p:sp>
+    </p:spTree>
+    <p:extLst>
+      <p:ext uri="{BB962C8B-B14F-4D97-AF65-F5344CB8AC3E}">
+        <p14:creationId xmlns:p14="http://schemas.microsoft.com/office/powerpoint/2010/main" val="3164086109"/>
+      </p:ext>
+    </p:extLst>
+  </p:cSld>
+  <p:clrMapOvr>
+    <a:masterClrMapping/>
+  </p:clrMapOvr>
+</p:sld>
+</file>
+
+<file path=ppt/slides/slide20.xml><?xml version="1.0" encoding="utf-8"?>
 <p:sld xmlns:a="http://schemas.openxmlformats.org/drawingml/2006/main" xmlns:r="http://schemas.openxmlformats.org/officeDocument/2006/relationships" xmlns:p="http://schemas.openxmlformats.org/presentationml/2006/main">
   <p:cSld>
     <p:spTree>
@@ -19739,7 +19591,7 @@
           <a:p>
             <a:fld id="{11B96697-4585-4368-989A-16003D150648}" type="datetime1">
               <a:rPr lang="de-CH" noProof="0" smtClean="0"/>
-              <a:t>10.10.2026</a:t>
+              <a:t>11.10.2026</a:t>
             </a:fld>
             <a:endParaRPr lang="de-CH" noProof="0"/>
           </a:p>
@@ -19797,7 +19649,7 @@
           <a:p>
             <a:fld id="{5ACA52AF-F19D-405C-AD5F-7D94B96A5CC3}" type="slidenum">
               <a:rPr lang="de-CH" noProof="0" smtClean="0"/>
-              <a:t>21</a:t>
+              <a:t>20</a:t>
             </a:fld>
             <a:endParaRPr lang="de-CH" noProof="0"/>
           </a:p>
@@ -19816,7 +19668,7 @@
 </p:sld>
 </file>
 
-<file path=ppt/slides/slide22.xml><?xml version="1.0" encoding="utf-8"?>
+<file path=ppt/slides/slide21.xml><?xml version="1.0" encoding="utf-8"?>
 <p:sld xmlns:a="http://schemas.openxmlformats.org/drawingml/2006/main" xmlns:r="http://schemas.openxmlformats.org/officeDocument/2006/relationships" xmlns:p="http://schemas.openxmlformats.org/presentationml/2006/main">
   <p:cSld>
     <p:spTree>
@@ -19891,7 +19743,7 @@
           <a:p>
             <a:fld id="{11B96697-4585-4368-989A-16003D150648}" type="datetime1">
               <a:rPr lang="de-CH" noProof="0" smtClean="0"/>
-              <a:t>10.10.2026</a:t>
+              <a:t>11.10.2026</a:t>
             </a:fld>
             <a:endParaRPr lang="de-CH" noProof="0"/>
           </a:p>
@@ -19949,7 +19801,7 @@
           <a:p>
             <a:fld id="{5ACA52AF-F19D-405C-AD5F-7D94B96A5CC3}" type="slidenum">
               <a:rPr lang="de-CH" noProof="0" smtClean="0"/>
-              <a:t>22</a:t>
+              <a:t>21</a:t>
             </a:fld>
             <a:endParaRPr lang="de-CH" noProof="0"/>
           </a:p>
@@ -20028,7 +19880,7 @@
 </p:sld>
 </file>
 
-<file path=ppt/slides/slide23.xml><?xml version="1.0" encoding="utf-8"?>
+<file path=ppt/slides/slide22.xml><?xml version="1.0" encoding="utf-8"?>
 <p:sld xmlns:a="http://schemas.openxmlformats.org/drawingml/2006/main" xmlns:r="http://schemas.openxmlformats.org/officeDocument/2006/relationships" xmlns:p="http://schemas.openxmlformats.org/presentationml/2006/main">
   <p:cSld>
     <p:spTree>
@@ -20097,7 +19949,7 @@
           <a:p>
             <a:fld id="{6C4EAFE7-317E-4912-B75C-DD6945F82242}" type="datetime1">
               <a:rPr lang="de-CH" noProof="0" smtClean="0"/>
-              <a:t>10.10.2026</a:t>
+              <a:t>11.10.2026</a:t>
             </a:fld>
             <a:endParaRPr lang="de-CH" noProof="0"/>
           </a:p>
@@ -20156,7 +20008,7 @@
             <a:fld id="{5ACA52AF-F19D-405C-AD5F-7D94B96A5CC3}" type="slidenum">
               <a:rPr lang="de-CH" noProof="0" smtClean="0"/>
               <a:pPr/>
-              <a:t>23</a:t>
+              <a:t>22</a:t>
             </a:fld>
             <a:endParaRPr lang="de-CH" noProof="0"/>
           </a:p>
@@ -20175,7 +20027,7 @@
 </p:sld>
 </file>
 
-<file path=ppt/slides/slide24.xml><?xml version="1.0" encoding="utf-8"?>
+<file path=ppt/slides/slide23.xml><?xml version="1.0" encoding="utf-8"?>
 <p:sld xmlns:a="http://schemas.openxmlformats.org/drawingml/2006/main" xmlns:r="http://schemas.openxmlformats.org/officeDocument/2006/relationships" xmlns:p="http://schemas.openxmlformats.org/presentationml/2006/main">
   <p:cSld>
     <p:spTree>
@@ -20913,7 +20765,7 @@
           <a:p>
             <a:fld id="{11B96697-4585-4368-989A-16003D150648}" type="datetime1">
               <a:rPr lang="de-CH" noProof="0" smtClean="0"/>
-              <a:t>10.10.2026</a:t>
+              <a:t>11.10.2026</a:t>
             </a:fld>
             <a:endParaRPr lang="de-CH" noProof="0"/>
           </a:p>
@@ -20971,7 +20823,7 @@
           <a:p>
             <a:fld id="{5ACA52AF-F19D-405C-AD5F-7D94B96A5CC3}" type="slidenum">
               <a:rPr lang="de-CH" noProof="0" smtClean="0"/>
-              <a:t>24</a:t>
+              <a:t>23</a:t>
             </a:fld>
             <a:endParaRPr lang="de-CH" noProof="0"/>
           </a:p>
@@ -20990,7 +20842,7 @@
 </p:sld>
 </file>
 
-<file path=ppt/slides/slide25.xml><?xml version="1.0" encoding="utf-8"?>
+<file path=ppt/slides/slide24.xml><?xml version="1.0" encoding="utf-8"?>
 <p:sld xmlns:a="http://schemas.openxmlformats.org/drawingml/2006/main" xmlns:r="http://schemas.openxmlformats.org/officeDocument/2006/relationships" xmlns:p="http://schemas.openxmlformats.org/presentationml/2006/main">
   <p:cSld>
     <p:spTree>
@@ -21044,8 +20896,8 @@
           </a:p>
         </p:txBody>
       </p:sp>
-      <mc:AlternateContent xmlns:mc="http://schemas.openxmlformats.org/markup-compatibility/2006">
-        <mc:Choice xmlns:a14="http://schemas.microsoft.com/office/drawing/2010/main" Requires="a14">
+      <mc:AlternateContent xmlns:mc="http://schemas.openxmlformats.org/markup-compatibility/2006" xmlns:a14="http://schemas.microsoft.com/office/drawing/2010/main">
+        <mc:Choice Requires="a14">
           <p:sp>
             <p:nvSpPr>
               <p:cNvPr id="3" name="Content Placeholder 2">
@@ -22432,7 +22284,7 @@
             </p:txBody>
           </p:sp>
         </mc:Choice>
-        <mc:Fallback>
+        <mc:Fallback xmlns="">
           <p:sp>
             <p:nvSpPr>
               <p:cNvPr id="3" name="Content Placeholder 2">
@@ -22495,7 +22347,7 @@
           <a:p>
             <a:fld id="{11B96697-4585-4368-989A-16003D150648}" type="datetime1">
               <a:rPr lang="de-CH" noProof="0" smtClean="0"/>
-              <a:t>10.10.2026</a:t>
+              <a:t>11.10.2026</a:t>
             </a:fld>
             <a:endParaRPr lang="de-CH" noProof="0"/>
           </a:p>
@@ -22553,7 +22405,7 @@
           <a:p>
             <a:fld id="{5ACA52AF-F19D-405C-AD5F-7D94B96A5CC3}" type="slidenum">
               <a:rPr lang="de-CH" noProof="0" smtClean="0"/>
-              <a:t>25</a:t>
+              <a:t>24</a:t>
             </a:fld>
             <a:endParaRPr lang="de-CH" noProof="0"/>
           </a:p>
@@ -22572,7 +22424,7 @@
 </p:sld>
 </file>
 
-<file path=ppt/slides/slide26.xml><?xml version="1.0" encoding="utf-8"?>
+<file path=ppt/slides/slide25.xml><?xml version="1.0" encoding="utf-8"?>
 <p:sld xmlns:a="http://schemas.openxmlformats.org/drawingml/2006/main" xmlns:r="http://schemas.openxmlformats.org/officeDocument/2006/relationships" xmlns:p="http://schemas.openxmlformats.org/presentationml/2006/main">
   <p:cSld>
     <p:spTree>
@@ -22685,7 +22537,7 @@
           <a:p>
             <a:fld id="{11B96697-4585-4368-989A-16003D150648}" type="datetime1">
               <a:rPr lang="de-CH" noProof="0" smtClean="0"/>
-              <a:t>10.10.2026</a:t>
+              <a:t>11.10.2026</a:t>
             </a:fld>
             <a:endParaRPr lang="de-CH" noProof="0"/>
           </a:p>
@@ -22743,7 +22595,7 @@
           <a:p>
             <a:fld id="{5ACA52AF-F19D-405C-AD5F-7D94B96A5CC3}" type="slidenum">
               <a:rPr lang="de-CH" noProof="0" smtClean="0"/>
-              <a:t>26</a:t>
+              <a:t>25</a:t>
             </a:fld>
             <a:endParaRPr lang="de-CH" noProof="0"/>
           </a:p>
@@ -22978,7 +22830,7 @@
 </p:sld>
 </file>
 
-<file path=ppt/slides/slide27.xml><?xml version="1.0" encoding="utf-8"?>
+<file path=ppt/slides/slide26.xml><?xml version="1.0" encoding="utf-8"?>
 <p:sld xmlns:a="http://schemas.openxmlformats.org/drawingml/2006/main" xmlns:r="http://schemas.openxmlformats.org/officeDocument/2006/relationships" xmlns:p="http://schemas.openxmlformats.org/presentationml/2006/main">
   <p:cSld>
     <p:spTree>
@@ -23578,7 +23430,7 @@
           <a:p>
             <a:fld id="{11B96697-4585-4368-989A-16003D150648}" type="datetime1">
               <a:rPr lang="de-CH" noProof="0" smtClean="0"/>
-              <a:t>10.10.2026</a:t>
+              <a:t>11.10.2026</a:t>
             </a:fld>
             <a:endParaRPr lang="de-CH" noProof="0"/>
           </a:p>
@@ -23636,7 +23488,7 @@
           <a:p>
             <a:fld id="{5ACA52AF-F19D-405C-AD5F-7D94B96A5CC3}" type="slidenum">
               <a:rPr lang="de-CH" noProof="0" smtClean="0"/>
-              <a:t>27</a:t>
+              <a:t>26</a:t>
             </a:fld>
             <a:endParaRPr lang="de-CH" noProof="0"/>
           </a:p>
@@ -23655,7 +23507,7 @@
 </p:sld>
 </file>
 
-<file path=ppt/slides/slide28.xml><?xml version="1.0" encoding="utf-8"?>
+<file path=ppt/slides/slide27.xml><?xml version="1.0" encoding="utf-8"?>
 <p:sld xmlns:a="http://schemas.openxmlformats.org/drawingml/2006/main" xmlns:r="http://schemas.openxmlformats.org/officeDocument/2006/relationships" xmlns:p="http://schemas.openxmlformats.org/presentationml/2006/main">
   <p:cSld>
     <p:spTree>
@@ -24092,7 +23944,7 @@
           <a:p>
             <a:fld id="{11B96697-4585-4368-989A-16003D150648}" type="datetime1">
               <a:rPr lang="de-CH" noProof="0" smtClean="0"/>
-              <a:t>10.10.2026</a:t>
+              <a:t>11.10.2026</a:t>
             </a:fld>
             <a:endParaRPr lang="de-CH" noProof="0"/>
           </a:p>
@@ -24150,7 +24002,7 @@
           <a:p>
             <a:fld id="{5ACA52AF-F19D-405C-AD5F-7D94B96A5CC3}" type="slidenum">
               <a:rPr lang="de-CH" noProof="0" smtClean="0"/>
-              <a:t>28</a:t>
+              <a:t>27</a:t>
             </a:fld>
             <a:endParaRPr lang="de-CH" noProof="0"/>
           </a:p>
@@ -24169,7 +24021,7 @@
 </p:sld>
 </file>
 
-<file path=ppt/slides/slide29.xml><?xml version="1.0" encoding="utf-8"?>
+<file path=ppt/slides/slide28.xml><?xml version="1.0" encoding="utf-8"?>
 <p:sld xmlns:a="http://schemas.openxmlformats.org/drawingml/2006/main" xmlns:r="http://schemas.openxmlformats.org/officeDocument/2006/relationships" xmlns:p="http://schemas.openxmlformats.org/presentationml/2006/main">
   <p:cSld>
     <p:spTree>
@@ -24282,7 +24134,7 @@
           <a:p>
             <a:fld id="{11B96697-4585-4368-989A-16003D150648}" type="datetime1">
               <a:rPr lang="de-CH" noProof="0" smtClean="0"/>
-              <a:t>10.10.2026</a:t>
+              <a:t>11.10.2026</a:t>
             </a:fld>
             <a:endParaRPr lang="de-CH" noProof="0"/>
           </a:p>
@@ -24340,7 +24192,7 @@
           <a:p>
             <a:fld id="{5ACA52AF-F19D-405C-AD5F-7D94B96A5CC3}" type="slidenum">
               <a:rPr lang="de-CH" noProof="0" smtClean="0"/>
-              <a:t>29</a:t>
+              <a:t>28</a:t>
             </a:fld>
             <a:endParaRPr lang="de-CH" noProof="0"/>
           </a:p>
@@ -24998,154 +24850,7 @@
 </p:sld>
 </file>
 
-<file path=ppt/slides/slide3.xml><?xml version="1.0" encoding="utf-8"?>
-<p:sld xmlns:a="http://schemas.openxmlformats.org/drawingml/2006/main" xmlns:r="http://schemas.openxmlformats.org/officeDocument/2006/relationships" xmlns:p="http://schemas.openxmlformats.org/presentationml/2006/main">
-  <p:cSld>
-    <p:spTree>
-      <p:nvGrpSpPr>
-        <p:cNvPr id="1" name=""/>
-        <p:cNvGrpSpPr/>
-        <p:nvPr/>
-      </p:nvGrpSpPr>
-      <p:grpSpPr>
-        <a:xfrm>
-          <a:off x="0" y="0"/>
-          <a:ext cx="0" cy="0"/>
-          <a:chOff x="0" y="0"/>
-          <a:chExt cx="0" cy="0"/>
-        </a:xfrm>
-      </p:grpSpPr>
-      <p:sp>
-        <p:nvSpPr>
-          <p:cNvPr id="2" name="Title 1">
-            <a:extLst>
-              <a:ext uri="{FF2B5EF4-FFF2-40B4-BE49-F238E27FC236}">
-                <a16:creationId xmlns:a16="http://schemas.microsoft.com/office/drawing/2014/main" id="{67B3B426-DF10-39FC-3293-8CF86202C625}"/>
-              </a:ext>
-            </a:extLst>
-          </p:cNvPr>
-          <p:cNvSpPr>
-            <a:spLocks noGrp="1"/>
-          </p:cNvSpPr>
-          <p:nvPr>
-            <p:ph type="title"/>
-          </p:nvPr>
-        </p:nvSpPr>
-        <p:spPr/>
-        <p:txBody>
-          <a:bodyPr/>
-          <a:lstStyle/>
-          <a:p>
-            <a:r>
-              <a:rPr lang="en-US" dirty="0"/>
-              <a:t>Chebyshev-Interpolation</a:t>
-            </a:r>
-            <a:endParaRPr lang="en-CH" dirty="0"/>
-          </a:p>
-        </p:txBody>
-      </p:sp>
-      <p:sp>
-        <p:nvSpPr>
-          <p:cNvPr id="3" name="Date Placeholder 2">
-            <a:extLst>
-              <a:ext uri="{FF2B5EF4-FFF2-40B4-BE49-F238E27FC236}">
-                <a16:creationId xmlns:a16="http://schemas.microsoft.com/office/drawing/2014/main" id="{AEE95860-970E-4DCD-AC8A-5F175D39DA26}"/>
-              </a:ext>
-            </a:extLst>
-          </p:cNvPr>
-          <p:cNvSpPr>
-            <a:spLocks noGrp="1"/>
-          </p:cNvSpPr>
-          <p:nvPr>
-            <p:ph type="dt" sz="half" idx="10"/>
-          </p:nvPr>
-        </p:nvSpPr>
-        <p:spPr/>
-        <p:txBody>
-          <a:bodyPr/>
-          <a:lstStyle/>
-          <a:p>
-            <a:fld id="{6C4EAFE7-317E-4912-B75C-DD6945F82242}" type="datetime1">
-              <a:rPr lang="de-CH" noProof="0" smtClean="0"/>
-              <a:t>10.10.2026</a:t>
-            </a:fld>
-            <a:endParaRPr lang="de-CH" noProof="0"/>
-          </a:p>
-        </p:txBody>
-      </p:sp>
-      <p:sp>
-        <p:nvSpPr>
-          <p:cNvPr id="4" name="Footer Placeholder 3">
-            <a:extLst>
-              <a:ext uri="{FF2B5EF4-FFF2-40B4-BE49-F238E27FC236}">
-                <a16:creationId xmlns:a16="http://schemas.microsoft.com/office/drawing/2014/main" id="{0DB1C382-D614-911E-89A4-70F284229E16}"/>
-              </a:ext>
-            </a:extLst>
-          </p:cNvPr>
-          <p:cNvSpPr>
-            <a:spLocks noGrp="1"/>
-          </p:cNvSpPr>
-          <p:nvPr>
-            <p:ph type="ftr" sz="quarter" idx="11"/>
-          </p:nvPr>
-        </p:nvSpPr>
-        <p:spPr/>
-        <p:txBody>
-          <a:bodyPr/>
-          <a:lstStyle/>
-          <a:p>
-            <a:r>
-              <a:rPr lang="de-DE" dirty="0"/>
-              <a:t>Department Informatik</a:t>
-            </a:r>
-            <a:endParaRPr lang="de-CH" noProof="0" dirty="0"/>
-          </a:p>
-        </p:txBody>
-      </p:sp>
-      <p:sp>
-        <p:nvSpPr>
-          <p:cNvPr id="5" name="Slide Number Placeholder 4">
-            <a:extLst>
-              <a:ext uri="{FF2B5EF4-FFF2-40B4-BE49-F238E27FC236}">
-                <a16:creationId xmlns:a16="http://schemas.microsoft.com/office/drawing/2014/main" id="{64EF6AEF-B382-6E10-972C-D701C760C091}"/>
-              </a:ext>
-            </a:extLst>
-          </p:cNvPr>
-          <p:cNvSpPr>
-            <a:spLocks noGrp="1"/>
-          </p:cNvSpPr>
-          <p:nvPr>
-            <p:ph type="sldNum" sz="quarter" idx="12"/>
-          </p:nvPr>
-        </p:nvSpPr>
-        <p:spPr/>
-        <p:txBody>
-          <a:bodyPr/>
-          <a:lstStyle/>
-          <a:p>
-            <a:fld id="{5ACA52AF-F19D-405C-AD5F-7D94B96A5CC3}" type="slidenum">
-              <a:rPr lang="de-CH" noProof="0" smtClean="0"/>
-              <a:pPr/>
-              <a:t>3</a:t>
-            </a:fld>
-            <a:endParaRPr lang="de-CH" noProof="0"/>
-          </a:p>
-        </p:txBody>
-      </p:sp>
-    </p:spTree>
-    <p:extLst>
-      <p:ext uri="{BB962C8B-B14F-4D97-AF65-F5344CB8AC3E}">
-        <p14:creationId xmlns:p14="http://schemas.microsoft.com/office/powerpoint/2010/main" val="4088133584"/>
-      </p:ext>
-    </p:extLst>
-  </p:cSld>
-  <p:clrMapOvr>
-    <a:masterClrMapping/>
-  </p:clrMapOvr>
-</p:sld>
-</file>
-
-<file path=ppt/slides/slide30.xml><?xml version="1.0" encoding="utf-8"?>
+<file path=ppt/slides/slide29.xml><?xml version="1.0" encoding="utf-8"?>
 <p:sld xmlns:a="http://schemas.openxmlformats.org/drawingml/2006/main" xmlns:r="http://schemas.openxmlformats.org/officeDocument/2006/relationships" xmlns:p="http://schemas.openxmlformats.org/presentationml/2006/main">
   <p:cSld>
     <p:spTree>
@@ -25258,7 +24963,7 @@
           <a:p>
             <a:fld id="{11B96697-4585-4368-989A-16003D150648}" type="datetime1">
               <a:rPr lang="de-CH" noProof="0" smtClean="0"/>
-              <a:t>10.10.2026</a:t>
+              <a:t>11.10.2026</a:t>
             </a:fld>
             <a:endParaRPr lang="de-CH" noProof="0"/>
           </a:p>
@@ -25316,7 +25021,7 @@
           <a:p>
             <a:fld id="{5ACA52AF-F19D-405C-AD5F-7D94B96A5CC3}" type="slidenum">
               <a:rPr lang="de-CH" noProof="0" smtClean="0"/>
-              <a:t>30</a:t>
+              <a:t>29</a:t>
             </a:fld>
             <a:endParaRPr lang="de-CH" noProof="0"/>
           </a:p>
@@ -25863,7 +25568,158 @@
 </p:sld>
 </file>
 
-<file path=ppt/slides/slide31.xml><?xml version="1.0" encoding="utf-8"?>
+<file path=ppt/slides/slide3.xml><?xml version="1.0" encoding="utf-8"?>
+<p:sld xmlns:a="http://schemas.openxmlformats.org/drawingml/2006/main" xmlns:r="http://schemas.openxmlformats.org/officeDocument/2006/relationships" xmlns:p="http://schemas.openxmlformats.org/presentationml/2006/main">
+  <p:cSld>
+    <p:spTree>
+      <p:nvGrpSpPr>
+        <p:cNvPr id="1" name=""/>
+        <p:cNvGrpSpPr/>
+        <p:nvPr/>
+      </p:nvGrpSpPr>
+      <p:grpSpPr>
+        <a:xfrm>
+          <a:off x="0" y="0"/>
+          <a:ext cx="0" cy="0"/>
+          <a:chOff x="0" y="0"/>
+          <a:chExt cx="0" cy="0"/>
+        </a:xfrm>
+      </p:grpSpPr>
+      <p:sp>
+        <p:nvSpPr>
+          <p:cNvPr id="2" name="Title 1">
+            <a:extLst>
+              <a:ext uri="{FF2B5EF4-FFF2-40B4-BE49-F238E27FC236}">
+                <a16:creationId xmlns:a16="http://schemas.microsoft.com/office/drawing/2014/main" id="{65377005-85D4-BB92-821C-BF5C5181E7D0}"/>
+              </a:ext>
+            </a:extLst>
+          </p:cNvPr>
+          <p:cNvSpPr>
+            <a:spLocks noGrp="1"/>
+          </p:cNvSpPr>
+          <p:nvPr>
+            <p:ph type="title"/>
+          </p:nvPr>
+        </p:nvSpPr>
+        <p:spPr/>
+        <p:txBody>
+          <a:bodyPr/>
+          <a:lstStyle/>
+          <a:p>
+            <a:r>
+              <a:rPr lang="en-US" dirty="0" err="1"/>
+              <a:t>Cosinus</a:t>
+            </a:r>
+            <a:r>
+              <a:rPr lang="en-US" dirty="0"/>
+              <a:t>-Transformation</a:t>
+            </a:r>
+            <a:endParaRPr lang="en-CH" dirty="0"/>
+          </a:p>
+        </p:txBody>
+      </p:sp>
+      <p:sp>
+        <p:nvSpPr>
+          <p:cNvPr id="3" name="Date Placeholder 2">
+            <a:extLst>
+              <a:ext uri="{FF2B5EF4-FFF2-40B4-BE49-F238E27FC236}">
+                <a16:creationId xmlns:a16="http://schemas.microsoft.com/office/drawing/2014/main" id="{F73FFF49-51BF-98EA-5D8A-45FDD6BA75AE}"/>
+              </a:ext>
+            </a:extLst>
+          </p:cNvPr>
+          <p:cNvSpPr>
+            <a:spLocks noGrp="1"/>
+          </p:cNvSpPr>
+          <p:nvPr>
+            <p:ph type="dt" sz="half" idx="10"/>
+          </p:nvPr>
+        </p:nvSpPr>
+        <p:spPr/>
+        <p:txBody>
+          <a:bodyPr/>
+          <a:lstStyle/>
+          <a:p>
+            <a:fld id="{6C4EAFE7-317E-4912-B75C-DD6945F82242}" type="datetime1">
+              <a:rPr lang="de-CH" noProof="0" smtClean="0"/>
+              <a:t>11.10.2026</a:t>
+            </a:fld>
+            <a:endParaRPr lang="de-CH" noProof="0"/>
+          </a:p>
+        </p:txBody>
+      </p:sp>
+      <p:sp>
+        <p:nvSpPr>
+          <p:cNvPr id="4" name="Footer Placeholder 3">
+            <a:extLst>
+              <a:ext uri="{FF2B5EF4-FFF2-40B4-BE49-F238E27FC236}">
+                <a16:creationId xmlns:a16="http://schemas.microsoft.com/office/drawing/2014/main" id="{8C98C872-7F8B-532A-DA7C-5EEA88A7D940}"/>
+              </a:ext>
+            </a:extLst>
+          </p:cNvPr>
+          <p:cNvSpPr>
+            <a:spLocks noGrp="1"/>
+          </p:cNvSpPr>
+          <p:nvPr>
+            <p:ph type="ftr" sz="quarter" idx="11"/>
+          </p:nvPr>
+        </p:nvSpPr>
+        <p:spPr/>
+        <p:txBody>
+          <a:bodyPr/>
+          <a:lstStyle/>
+          <a:p>
+            <a:r>
+              <a:rPr lang="de-DE"/>
+              <a:t>Department Informatik</a:t>
+            </a:r>
+            <a:endParaRPr lang="de-CH" noProof="0" dirty="0"/>
+          </a:p>
+        </p:txBody>
+      </p:sp>
+      <p:sp>
+        <p:nvSpPr>
+          <p:cNvPr id="5" name="Slide Number Placeholder 4">
+            <a:extLst>
+              <a:ext uri="{FF2B5EF4-FFF2-40B4-BE49-F238E27FC236}">
+                <a16:creationId xmlns:a16="http://schemas.microsoft.com/office/drawing/2014/main" id="{0A0630A9-8887-FB97-88A6-BACC0CD6C5E4}"/>
+              </a:ext>
+            </a:extLst>
+          </p:cNvPr>
+          <p:cNvSpPr>
+            <a:spLocks noGrp="1"/>
+          </p:cNvSpPr>
+          <p:nvPr>
+            <p:ph type="sldNum" sz="quarter" idx="12"/>
+          </p:nvPr>
+        </p:nvSpPr>
+        <p:spPr/>
+        <p:txBody>
+          <a:bodyPr/>
+          <a:lstStyle/>
+          <a:p>
+            <a:fld id="{5ACA52AF-F19D-405C-AD5F-7D94B96A5CC3}" type="slidenum">
+              <a:rPr lang="de-CH" noProof="0" smtClean="0"/>
+              <a:pPr/>
+              <a:t>3</a:t>
+            </a:fld>
+            <a:endParaRPr lang="de-CH" noProof="0"/>
+          </a:p>
+        </p:txBody>
+      </p:sp>
+    </p:spTree>
+    <p:extLst>
+      <p:ext uri="{BB962C8B-B14F-4D97-AF65-F5344CB8AC3E}">
+        <p14:creationId xmlns:p14="http://schemas.microsoft.com/office/powerpoint/2010/main" val="1081121242"/>
+      </p:ext>
+    </p:extLst>
+  </p:cSld>
+  <p:clrMapOvr>
+    <a:masterClrMapping/>
+  </p:clrMapOvr>
+</p:sld>
+</file>
+
+<file path=ppt/slides/slide30.xml><?xml version="1.0" encoding="utf-8"?>
 <p:sld xmlns:a="http://schemas.openxmlformats.org/drawingml/2006/main" xmlns:r="http://schemas.openxmlformats.org/officeDocument/2006/relationships" xmlns:p="http://schemas.openxmlformats.org/presentationml/2006/main">
   <p:cSld>
     <p:spTree>
@@ -26454,7 +26310,7 @@
           <a:p>
             <a:fld id="{11B96697-4585-4368-989A-16003D150648}" type="datetime1">
               <a:rPr lang="de-CH" noProof="0" smtClean="0"/>
-              <a:t>10.10.2026</a:t>
+              <a:t>11.10.2026</a:t>
             </a:fld>
             <a:endParaRPr lang="de-CH" noProof="0"/>
           </a:p>
@@ -26512,7 +26368,7 @@
           <a:p>
             <a:fld id="{5ACA52AF-F19D-405C-AD5F-7D94B96A5CC3}" type="slidenum">
               <a:rPr lang="de-CH" noProof="0" smtClean="0"/>
-              <a:t>31</a:t>
+              <a:t>30</a:t>
             </a:fld>
             <a:endParaRPr lang="de-CH" noProof="0"/>
           </a:p>
@@ -26561,7 +26417,7 @@
 </p:sld>
 </file>
 
-<file path=ppt/slides/slide32.xml><?xml version="1.0" encoding="utf-8"?>
+<file path=ppt/slides/slide31.xml><?xml version="1.0" encoding="utf-8"?>
 <p:sld xmlns:a="http://schemas.openxmlformats.org/drawingml/2006/main" xmlns:r="http://schemas.openxmlformats.org/officeDocument/2006/relationships" xmlns:p="http://schemas.openxmlformats.org/presentationml/2006/main">
   <p:cSld>
     <p:spTree>
@@ -26998,7 +26854,7 @@
           <a:p>
             <a:fld id="{11B96697-4585-4368-989A-16003D150648}" type="datetime1">
               <a:rPr lang="de-CH" noProof="0" smtClean="0"/>
-              <a:t>10.10.2026</a:t>
+              <a:t>11.10.2026</a:t>
             </a:fld>
             <a:endParaRPr lang="de-CH" noProof="0"/>
           </a:p>
@@ -27056,7 +26912,7 @@
           <a:p>
             <a:fld id="{5ACA52AF-F19D-405C-AD5F-7D94B96A5CC3}" type="slidenum">
               <a:rPr lang="de-CH" noProof="0" smtClean="0"/>
-              <a:t>32</a:t>
+              <a:t>31</a:t>
             </a:fld>
             <a:endParaRPr lang="de-CH" noProof="0"/>
           </a:p>
@@ -27075,7 +26931,7 @@
 </p:sld>
 </file>
 
-<file path=ppt/slides/slide33.xml><?xml version="1.0" encoding="utf-8"?>
+<file path=ppt/slides/slide32.xml><?xml version="1.0" encoding="utf-8"?>
 <p:sld xmlns:a="http://schemas.openxmlformats.org/drawingml/2006/main" xmlns:r="http://schemas.openxmlformats.org/officeDocument/2006/relationships" xmlns:p="http://schemas.openxmlformats.org/presentationml/2006/main">
   <p:cSld>
     <p:spTree>
@@ -27205,336 +27061,6 @@
           <p:cNvPr id="2" name="Title 1">
             <a:extLst>
               <a:ext uri="{FF2B5EF4-FFF2-40B4-BE49-F238E27FC236}">
-                <a16:creationId xmlns:a16="http://schemas.microsoft.com/office/drawing/2014/main" id="{16DA91A0-07DD-7EDE-11C7-3D119A0B2201}"/>
-              </a:ext>
-            </a:extLst>
-          </p:cNvPr>
-          <p:cNvSpPr>
-            <a:spLocks noGrp="1"/>
-          </p:cNvSpPr>
-          <p:nvPr>
-            <p:ph type="title"/>
-          </p:nvPr>
-        </p:nvSpPr>
-        <p:spPr/>
-        <p:txBody>
-          <a:bodyPr/>
-          <a:lstStyle/>
-          <a:p>
-            <a:r>
-              <a:rPr lang="en-US" dirty="0"/>
-              <a:t>Content Slide 1</a:t>
-            </a:r>
-            <a:endParaRPr lang="en-CH" dirty="0"/>
-          </a:p>
-        </p:txBody>
-      </p:sp>
-      <p:sp>
-        <p:nvSpPr>
-          <p:cNvPr id="17" name="Content Placeholder 2">
-            <a:extLst>
-              <a:ext uri="{FF2B5EF4-FFF2-40B4-BE49-F238E27FC236}">
-                <a16:creationId xmlns:a16="http://schemas.microsoft.com/office/drawing/2014/main" id="{EE892D8D-F417-3DA6-7FCD-AC59D8FA6F62}"/>
-              </a:ext>
-            </a:extLst>
-          </p:cNvPr>
-          <p:cNvSpPr>
-            <a:spLocks noGrp="1"/>
-          </p:cNvSpPr>
-          <p:nvPr>
-            <p:ph idx="1"/>
-          </p:nvPr>
-        </p:nvSpPr>
-        <p:spPr>
-          <a:xfrm>
-            <a:off x="731837" y="1412875"/>
-            <a:ext cx="10728325" cy="4680000"/>
-          </a:xfrm>
-        </p:spPr>
-        <p:txBody>
-          <a:bodyPr/>
-          <a:lstStyle/>
-          <a:p>
-            <a:pPr marL="0" indent="0">
-              <a:buNone/>
-            </a:pPr>
-            <a:endParaRPr lang="en-US" dirty="0"/>
-          </a:p>
-        </p:txBody>
-      </p:sp>
-      <p:sp>
-        <p:nvSpPr>
-          <p:cNvPr id="4" name="Date Placeholder 3">
-            <a:extLst>
-              <a:ext uri="{FF2B5EF4-FFF2-40B4-BE49-F238E27FC236}">
-                <a16:creationId xmlns:a16="http://schemas.microsoft.com/office/drawing/2014/main" id="{8E8D3CA0-FE23-CF8E-B9EB-EAAF10B818DF}"/>
-              </a:ext>
-            </a:extLst>
-          </p:cNvPr>
-          <p:cNvSpPr>
-            <a:spLocks noGrp="1"/>
-          </p:cNvSpPr>
-          <p:nvPr>
-            <p:ph type="dt" sz="half" idx="10"/>
-          </p:nvPr>
-        </p:nvSpPr>
-        <p:spPr/>
-        <p:txBody>
-          <a:bodyPr/>
-          <a:lstStyle/>
-          <a:p>
-            <a:fld id="{11B96697-4585-4368-989A-16003D150648}" type="datetime1">
-              <a:rPr lang="de-CH" noProof="0" smtClean="0"/>
-              <a:t>10.10.2026</a:t>
-            </a:fld>
-            <a:endParaRPr lang="de-CH" noProof="0"/>
-          </a:p>
-        </p:txBody>
-      </p:sp>
-      <p:sp>
-        <p:nvSpPr>
-          <p:cNvPr id="5" name="Footer Placeholder 4">
-            <a:extLst>
-              <a:ext uri="{FF2B5EF4-FFF2-40B4-BE49-F238E27FC236}">
-                <a16:creationId xmlns:a16="http://schemas.microsoft.com/office/drawing/2014/main" id="{31461F50-E712-9D86-1380-192FBAB1C019}"/>
-              </a:ext>
-            </a:extLst>
-          </p:cNvPr>
-          <p:cNvSpPr>
-            <a:spLocks noGrp="1"/>
-          </p:cNvSpPr>
-          <p:nvPr>
-            <p:ph type="ftr" sz="quarter" idx="11"/>
-          </p:nvPr>
-        </p:nvSpPr>
-        <p:spPr/>
-        <p:txBody>
-          <a:bodyPr/>
-          <a:lstStyle/>
-          <a:p>
-            <a:r>
-              <a:rPr lang="de-DE" dirty="0"/>
-              <a:t>Department Informatik</a:t>
-            </a:r>
-            <a:endParaRPr lang="de-CH" noProof="0" dirty="0"/>
-          </a:p>
-        </p:txBody>
-      </p:sp>
-      <p:sp>
-        <p:nvSpPr>
-          <p:cNvPr id="6" name="Slide Number Placeholder 5">
-            <a:extLst>
-              <a:ext uri="{FF2B5EF4-FFF2-40B4-BE49-F238E27FC236}">
-                <a16:creationId xmlns:a16="http://schemas.microsoft.com/office/drawing/2014/main" id="{0D9E2D06-44EA-8566-E6DF-F71F9653231A}"/>
-              </a:ext>
-            </a:extLst>
-          </p:cNvPr>
-          <p:cNvSpPr>
-            <a:spLocks noGrp="1"/>
-          </p:cNvSpPr>
-          <p:nvPr>
-            <p:ph type="sldNum" sz="quarter" idx="12"/>
-          </p:nvPr>
-        </p:nvSpPr>
-        <p:spPr/>
-        <p:txBody>
-          <a:bodyPr/>
-          <a:lstStyle/>
-          <a:p>
-            <a:fld id="{5ACA52AF-F19D-405C-AD5F-7D94B96A5CC3}" type="slidenum">
-              <a:rPr lang="de-CH" noProof="0" smtClean="0"/>
-              <a:t>4</a:t>
-            </a:fld>
-            <a:endParaRPr lang="de-CH" noProof="0"/>
-          </a:p>
-        </p:txBody>
-      </p:sp>
-    </p:spTree>
-    <p:extLst>
-      <p:ext uri="{BB962C8B-B14F-4D97-AF65-F5344CB8AC3E}">
-        <p14:creationId xmlns:p14="http://schemas.microsoft.com/office/powerpoint/2010/main" val="3182448369"/>
-      </p:ext>
-    </p:extLst>
-  </p:cSld>
-  <p:clrMapOvr>
-    <a:masterClrMapping/>
-  </p:clrMapOvr>
-</p:sld>
-</file>
-
-<file path=ppt/slides/slide5.xml><?xml version="1.0" encoding="utf-8"?>
-<p:sld xmlns:a="http://schemas.openxmlformats.org/drawingml/2006/main" xmlns:r="http://schemas.openxmlformats.org/officeDocument/2006/relationships" xmlns:p="http://schemas.openxmlformats.org/presentationml/2006/main">
-  <p:cSld>
-    <p:spTree>
-      <p:nvGrpSpPr>
-        <p:cNvPr id="1" name=""/>
-        <p:cNvGrpSpPr/>
-        <p:nvPr/>
-      </p:nvGrpSpPr>
-      <p:grpSpPr>
-        <a:xfrm>
-          <a:off x="0" y="0"/>
-          <a:ext cx="0" cy="0"/>
-          <a:chOff x="0" y="0"/>
-          <a:chExt cx="0" cy="0"/>
-        </a:xfrm>
-      </p:grpSpPr>
-      <p:sp>
-        <p:nvSpPr>
-          <p:cNvPr id="2" name="Title 1">
-            <a:extLst>
-              <a:ext uri="{FF2B5EF4-FFF2-40B4-BE49-F238E27FC236}">
-                <a16:creationId xmlns:a16="http://schemas.microsoft.com/office/drawing/2014/main" id="{65377005-85D4-BB92-821C-BF5C5181E7D0}"/>
-              </a:ext>
-            </a:extLst>
-          </p:cNvPr>
-          <p:cNvSpPr>
-            <a:spLocks noGrp="1"/>
-          </p:cNvSpPr>
-          <p:nvPr>
-            <p:ph type="title"/>
-          </p:nvPr>
-        </p:nvSpPr>
-        <p:spPr/>
-        <p:txBody>
-          <a:bodyPr/>
-          <a:lstStyle/>
-          <a:p>
-            <a:r>
-              <a:rPr lang="en-US" dirty="0" err="1"/>
-              <a:t>Cosinus</a:t>
-            </a:r>
-            <a:r>
-              <a:rPr lang="en-US" dirty="0"/>
-              <a:t>-Transformation</a:t>
-            </a:r>
-            <a:endParaRPr lang="en-CH" dirty="0"/>
-          </a:p>
-        </p:txBody>
-      </p:sp>
-      <p:sp>
-        <p:nvSpPr>
-          <p:cNvPr id="3" name="Date Placeholder 2">
-            <a:extLst>
-              <a:ext uri="{FF2B5EF4-FFF2-40B4-BE49-F238E27FC236}">
-                <a16:creationId xmlns:a16="http://schemas.microsoft.com/office/drawing/2014/main" id="{F73FFF49-51BF-98EA-5D8A-45FDD6BA75AE}"/>
-              </a:ext>
-            </a:extLst>
-          </p:cNvPr>
-          <p:cNvSpPr>
-            <a:spLocks noGrp="1"/>
-          </p:cNvSpPr>
-          <p:nvPr>
-            <p:ph type="dt" sz="half" idx="10"/>
-          </p:nvPr>
-        </p:nvSpPr>
-        <p:spPr/>
-        <p:txBody>
-          <a:bodyPr/>
-          <a:lstStyle/>
-          <a:p>
-            <a:fld id="{6C4EAFE7-317E-4912-B75C-DD6945F82242}" type="datetime1">
-              <a:rPr lang="de-CH" noProof="0" smtClean="0"/>
-              <a:t>10.10.2026</a:t>
-            </a:fld>
-            <a:endParaRPr lang="de-CH" noProof="0"/>
-          </a:p>
-        </p:txBody>
-      </p:sp>
-      <p:sp>
-        <p:nvSpPr>
-          <p:cNvPr id="4" name="Footer Placeholder 3">
-            <a:extLst>
-              <a:ext uri="{FF2B5EF4-FFF2-40B4-BE49-F238E27FC236}">
-                <a16:creationId xmlns:a16="http://schemas.microsoft.com/office/drawing/2014/main" id="{8C98C872-7F8B-532A-DA7C-5EEA88A7D940}"/>
-              </a:ext>
-            </a:extLst>
-          </p:cNvPr>
-          <p:cNvSpPr>
-            <a:spLocks noGrp="1"/>
-          </p:cNvSpPr>
-          <p:nvPr>
-            <p:ph type="ftr" sz="quarter" idx="11"/>
-          </p:nvPr>
-        </p:nvSpPr>
-        <p:spPr/>
-        <p:txBody>
-          <a:bodyPr/>
-          <a:lstStyle/>
-          <a:p>
-            <a:r>
-              <a:rPr lang="de-DE"/>
-              <a:t>Department Informatik</a:t>
-            </a:r>
-            <a:endParaRPr lang="de-CH" noProof="0" dirty="0"/>
-          </a:p>
-        </p:txBody>
-      </p:sp>
-      <p:sp>
-        <p:nvSpPr>
-          <p:cNvPr id="5" name="Slide Number Placeholder 4">
-            <a:extLst>
-              <a:ext uri="{FF2B5EF4-FFF2-40B4-BE49-F238E27FC236}">
-                <a16:creationId xmlns:a16="http://schemas.microsoft.com/office/drawing/2014/main" id="{0A0630A9-8887-FB97-88A6-BACC0CD6C5E4}"/>
-              </a:ext>
-            </a:extLst>
-          </p:cNvPr>
-          <p:cNvSpPr>
-            <a:spLocks noGrp="1"/>
-          </p:cNvSpPr>
-          <p:nvPr>
-            <p:ph type="sldNum" sz="quarter" idx="12"/>
-          </p:nvPr>
-        </p:nvSpPr>
-        <p:spPr/>
-        <p:txBody>
-          <a:bodyPr/>
-          <a:lstStyle/>
-          <a:p>
-            <a:fld id="{5ACA52AF-F19D-405C-AD5F-7D94B96A5CC3}" type="slidenum">
-              <a:rPr lang="de-CH" noProof="0" smtClean="0"/>
-              <a:pPr/>
-              <a:t>5</a:t>
-            </a:fld>
-            <a:endParaRPr lang="de-CH" noProof="0"/>
-          </a:p>
-        </p:txBody>
-      </p:sp>
-    </p:spTree>
-    <p:extLst>
-      <p:ext uri="{BB962C8B-B14F-4D97-AF65-F5344CB8AC3E}">
-        <p14:creationId xmlns:p14="http://schemas.microsoft.com/office/powerpoint/2010/main" val="1081121242"/>
-      </p:ext>
-    </p:extLst>
-  </p:cSld>
-  <p:clrMapOvr>
-    <a:masterClrMapping/>
-  </p:clrMapOvr>
-</p:sld>
-</file>
-
-<file path=ppt/slides/slide6.xml><?xml version="1.0" encoding="utf-8"?>
-<p:sld xmlns:a="http://schemas.openxmlformats.org/drawingml/2006/main" xmlns:r="http://schemas.openxmlformats.org/officeDocument/2006/relationships" xmlns:p="http://schemas.openxmlformats.org/presentationml/2006/main">
-  <p:cSld>
-    <p:spTree>
-      <p:nvGrpSpPr>
-        <p:cNvPr id="1" name=""/>
-        <p:cNvGrpSpPr/>
-        <p:nvPr/>
-      </p:nvGrpSpPr>
-      <p:grpSpPr>
-        <a:xfrm>
-          <a:off x="0" y="0"/>
-          <a:ext cx="0" cy="0"/>
-          <a:chOff x="0" y="0"/>
-          <a:chExt cx="0" cy="0"/>
-        </a:xfrm>
-      </p:grpSpPr>
-      <p:sp>
-        <p:nvSpPr>
-          <p:cNvPr id="2" name="Title 1">
-            <a:extLst>
-              <a:ext uri="{FF2B5EF4-FFF2-40B4-BE49-F238E27FC236}">
                 <a16:creationId xmlns:a16="http://schemas.microsoft.com/office/drawing/2014/main" id="{E26CE708-728A-928E-9737-D362215B8D45}"/>
               </a:ext>
             </a:extLst>
@@ -27586,7 +27112,7 @@
           <a:p>
             <a:fld id="{11B96697-4585-4368-989A-16003D150648}" type="datetime1">
               <a:rPr lang="de-CH" noProof="0" smtClean="0"/>
-              <a:t>10.10.2026</a:t>
+              <a:t>11.10.2026</a:t>
             </a:fld>
             <a:endParaRPr lang="de-CH" noProof="0"/>
           </a:p>
@@ -27644,7 +27170,7 @@
           <a:p>
             <a:fld id="{5ACA52AF-F19D-405C-AD5F-7D94B96A5CC3}" type="slidenum">
               <a:rPr lang="de-CH" noProof="0" smtClean="0"/>
-              <a:t>6</a:t>
+              <a:t>4</a:t>
             </a:fld>
             <a:endParaRPr lang="de-CH" noProof="0"/>
           </a:p>
@@ -28447,7 +27973,7 @@
 </p:sld>
 </file>
 
-<file path=ppt/slides/slide7.xml><?xml version="1.0" encoding="utf-8"?>
+<file path=ppt/slides/slide5.xml><?xml version="1.0" encoding="utf-8"?>
 <p:sld xmlns:a="http://schemas.openxmlformats.org/drawingml/2006/main" xmlns:r="http://schemas.openxmlformats.org/officeDocument/2006/relationships" xmlns:p="http://schemas.openxmlformats.org/presentationml/2006/main">
   <p:cSld>
     <p:spTree>
@@ -29173,7 +28699,7 @@
           <a:p>
             <a:fld id="{11B96697-4585-4368-989A-16003D150648}" type="datetime1">
               <a:rPr lang="de-CH" noProof="0" smtClean="0"/>
-              <a:t>10.10.2026</a:t>
+              <a:t>11.10.2026</a:t>
             </a:fld>
             <a:endParaRPr lang="de-CH" noProof="0"/>
           </a:p>
@@ -29231,7 +28757,7 @@
           <a:p>
             <a:fld id="{5ACA52AF-F19D-405C-AD5F-7D94B96A5CC3}" type="slidenum">
               <a:rPr lang="de-CH" noProof="0" smtClean="0"/>
-              <a:t>7</a:t>
+              <a:t>5</a:t>
             </a:fld>
             <a:endParaRPr lang="de-CH" noProof="0"/>
           </a:p>
@@ -29450,7 +28976,7 @@
 </p:sld>
 </file>
 
-<file path=ppt/slides/slide8.xml><?xml version="1.0" encoding="utf-8"?>
+<file path=ppt/slides/slide6.xml><?xml version="1.0" encoding="utf-8"?>
 <p:sld xmlns:a="http://schemas.openxmlformats.org/drawingml/2006/main" xmlns:r="http://schemas.openxmlformats.org/officeDocument/2006/relationships" xmlns:p="http://schemas.openxmlformats.org/presentationml/2006/main">
   <p:cSld>
     <p:spTree>
@@ -29537,7 +29063,7 @@
           <a:p>
             <a:fld id="{11B96697-4585-4368-989A-16003D150648}" type="datetime1">
               <a:rPr lang="de-CH" noProof="0" smtClean="0"/>
-              <a:t>10.10.2026</a:t>
+              <a:t>11.10.2026</a:t>
             </a:fld>
             <a:endParaRPr lang="de-CH" noProof="0"/>
           </a:p>
@@ -29595,7 +29121,7 @@
           <a:p>
             <a:fld id="{5ACA52AF-F19D-405C-AD5F-7D94B96A5CC3}" type="slidenum">
               <a:rPr lang="de-CH" noProof="0" smtClean="0"/>
-              <a:t>8</a:t>
+              <a:t>6</a:t>
             </a:fld>
             <a:endParaRPr lang="de-CH" noProof="0"/>
           </a:p>
@@ -30793,7 +30319,1480 @@
 </p:sld>
 </file>
 
-<file path=ppt/slides/slide9.xml><?xml version="1.0" encoding="utf-8"?>
+<file path=ppt/slides/slide7.xml><?xml version="1.0" encoding="utf-8"?>
+<p:sld xmlns:a="http://schemas.openxmlformats.org/drawingml/2006/main" xmlns:r="http://schemas.openxmlformats.org/officeDocument/2006/relationships" xmlns:p="http://schemas.openxmlformats.org/presentationml/2006/main">
+  <p:cSld>
+    <p:spTree>
+      <p:nvGrpSpPr>
+        <p:cNvPr id="1" name=""/>
+        <p:cNvGrpSpPr/>
+        <p:nvPr/>
+      </p:nvGrpSpPr>
+      <p:grpSpPr>
+        <a:xfrm>
+          <a:off x="0" y="0"/>
+          <a:ext cx="0" cy="0"/>
+          <a:chOff x="0" y="0"/>
+          <a:chExt cx="0" cy="0"/>
+        </a:xfrm>
+      </p:grpSpPr>
+      <p:sp>
+        <p:nvSpPr>
+          <p:cNvPr id="2" name="Title 1">
+            <a:extLst>
+              <a:ext uri="{FF2B5EF4-FFF2-40B4-BE49-F238E27FC236}">
+                <a16:creationId xmlns:a16="http://schemas.microsoft.com/office/drawing/2014/main" id="{FA360B84-7FF6-2452-42EF-32234D20BFF0}"/>
+              </a:ext>
+            </a:extLst>
+          </p:cNvPr>
+          <p:cNvSpPr>
+            <a:spLocks noGrp="1"/>
+          </p:cNvSpPr>
+          <p:nvPr>
+            <p:ph type="title"/>
+          </p:nvPr>
+        </p:nvSpPr>
+        <p:spPr/>
+        <p:txBody>
+          <a:bodyPr/>
+          <a:lstStyle/>
+          <a:p>
+            <a:r>
+              <a:rPr lang="en-US" dirty="0" err="1"/>
+              <a:t>Cosinus</a:t>
+            </a:r>
+            <a:r>
+              <a:rPr lang="en-US" dirty="0"/>
+              <a:t>-Transformation: </a:t>
+            </a:r>
+            <a:r>
+              <a:rPr lang="en-US" dirty="0" err="1"/>
+              <a:t>Vorgehen</a:t>
+            </a:r>
+            <a:endParaRPr lang="en-CH" dirty="0"/>
+          </a:p>
+        </p:txBody>
+      </p:sp>
+      <mc:AlternateContent xmlns:mc="http://schemas.openxmlformats.org/markup-compatibility/2006">
+        <mc:Choice xmlns:a14="http://schemas.microsoft.com/office/drawing/2010/main" Requires="a14">
+          <p:sp>
+            <p:nvSpPr>
+              <p:cNvPr id="3" name="Content Placeholder 2">
+                <a:extLst>
+                  <a:ext uri="{FF2B5EF4-FFF2-40B4-BE49-F238E27FC236}">
+                    <a16:creationId xmlns:a16="http://schemas.microsoft.com/office/drawing/2014/main" id="{288B89D9-43D9-95E7-21F3-7D737FDB0F6F}"/>
+                  </a:ext>
+                </a:extLst>
+              </p:cNvPr>
+              <p:cNvSpPr>
+                <a:spLocks noGrp="1"/>
+              </p:cNvSpPr>
+              <p:nvPr>
+                <p:ph idx="1"/>
+              </p:nvPr>
+            </p:nvSpPr>
+            <p:spPr/>
+            <p:txBody>
+              <a:bodyPr/>
+              <a:lstStyle/>
+              <a:p>
+                <a:r>
+                  <a:rPr lang="en-US" dirty="0"/>
+                  <a:t>Wir </a:t>
+                </a:r>
+                <a:r>
+                  <a:rPr lang="en-US" dirty="0" err="1"/>
+                  <a:t>messen</a:t>
+                </a:r>
+                <a:r>
+                  <a:rPr lang="en-US" dirty="0"/>
+                  <a:t> </a:t>
+                </a:r>
+                <a14:m>
+                  <m:oMath xmlns:m="http://schemas.openxmlformats.org/officeDocument/2006/math">
+                    <m:r>
+                      <a:rPr lang="en-US" b="0" i="1" smtClean="0">
+                        <a:latin typeface="Cambria Math" panose="02040503050406030204" pitchFamily="18" charset="0"/>
+                      </a:rPr>
+                      <m:t>𝑓</m:t>
+                    </m:r>
+                  </m:oMath>
+                </a14:m>
+                <a:r>
+                  <a:rPr lang="en-US" dirty="0"/>
+                  <a:t> an den </a:t>
+                </a:r>
+                <a:r>
+                  <a:rPr lang="en-US" dirty="0" err="1"/>
+                  <a:t>Stellen</a:t>
+                </a:r>
+                <a:r>
+                  <a:rPr lang="en-US" dirty="0"/>
+                  <a:t> </a:t>
+                </a:r>
+                <a14:m>
+                  <m:oMath xmlns:m="http://schemas.openxmlformats.org/officeDocument/2006/math">
+                    <m:sSub>
+                      <m:sSubPr>
+                        <m:ctrlPr>
+                          <a:rPr lang="en-US" b="0" i="1" smtClean="0">
+                            <a:latin typeface="Cambria Math" panose="02040503050406030204" pitchFamily="18" charset="0"/>
+                          </a:rPr>
+                        </m:ctrlPr>
+                      </m:sSubPr>
+                      <m:e>
+                        <m:r>
+                          <a:rPr lang="en-US" b="0" i="1" smtClean="0">
+                            <a:latin typeface="Cambria Math" panose="02040503050406030204" pitchFamily="18" charset="0"/>
+                          </a:rPr>
+                          <m:t>𝑡</m:t>
+                        </m:r>
+                      </m:e>
+                      <m:sub>
+                        <m:r>
+                          <a:rPr lang="en-US" b="0" i="1" smtClean="0">
+                            <a:latin typeface="Cambria Math" panose="02040503050406030204" pitchFamily="18" charset="0"/>
+                          </a:rPr>
+                          <m:t>𝑘</m:t>
+                        </m:r>
+                      </m:sub>
+                    </m:sSub>
+                  </m:oMath>
+                </a14:m>
+                <a:r>
+                  <a:rPr lang="en-US" dirty="0"/>
+                  <a:t> und </a:t>
+                </a:r>
+                <a:r>
+                  <a:rPr lang="en-US" dirty="0" err="1"/>
+                  <a:t>bekommen</a:t>
+                </a:r>
+                <a:r>
+                  <a:rPr lang="en-US" dirty="0"/>
+                  <a:t> </a:t>
+                </a:r>
+                <a14:m>
+                  <m:oMath xmlns:m="http://schemas.openxmlformats.org/officeDocument/2006/math">
+                    <m:r>
+                      <a:rPr lang="en-US" b="0" i="1" smtClean="0">
+                        <a:latin typeface="Cambria Math" panose="02040503050406030204" pitchFamily="18" charset="0"/>
+                      </a:rPr>
+                      <m:t>𝑦</m:t>
+                    </m:r>
+                    <m:r>
+                      <a:rPr lang="en-US">
+                        <a:ea typeface="Cambria Math" panose="02040503050406030204" pitchFamily="18" charset="0"/>
+                      </a:rPr>
+                      <m:t>→</m:t>
+                    </m:r>
+                    <m:r>
+                      <m:rPr>
+                        <m:sty m:val="p"/>
+                      </m:rPr>
+                      <a:rPr lang="en-US" b="0" i="0" smtClean="0">
+                        <a:latin typeface="Cambria Math" panose="02040503050406030204" pitchFamily="18" charset="0"/>
+                        <a:ea typeface="Cambria Math" panose="02040503050406030204" pitchFamily="18" charset="0"/>
+                      </a:rPr>
+                      <m:t>z</m:t>
+                    </m:r>
+                  </m:oMath>
+                </a14:m>
+                <a:endParaRPr lang="en-US" dirty="0"/>
+              </a:p>
+              <a:p>
+                <a:r>
+                  <a:rPr lang="en-US" dirty="0"/>
+                  <a:t>Wir tun so, </a:t>
+                </a:r>
+                <a:r>
+                  <a:rPr lang="en-US" dirty="0" err="1"/>
+                  <a:t>als</a:t>
+                </a:r>
+                <a:r>
+                  <a:rPr lang="en-US" dirty="0"/>
+                  <a:t> </a:t>
+                </a:r>
+                <a:r>
+                  <a:rPr lang="en-US" dirty="0" err="1"/>
+                  <a:t>hätten</a:t>
+                </a:r>
+                <a:r>
+                  <a:rPr lang="en-US" dirty="0"/>
+                  <a:t> </a:t>
+                </a:r>
+                <a:r>
+                  <a:rPr lang="en-US" dirty="0" err="1"/>
+                  <a:t>wir</a:t>
+                </a:r>
+                <a:r>
+                  <a:rPr lang="en-US" dirty="0"/>
+                  <a:t> an </a:t>
+                </a:r>
+                <a14:m>
+                  <m:oMath xmlns:m="http://schemas.openxmlformats.org/officeDocument/2006/math">
+                    <m:sSub>
+                      <m:sSubPr>
+                        <m:ctrlPr>
+                          <a:rPr lang="en-US" b="0" i="1" smtClean="0">
+                            <a:latin typeface="Cambria Math" panose="02040503050406030204" pitchFamily="18" charset="0"/>
+                          </a:rPr>
+                        </m:ctrlPr>
+                      </m:sSubPr>
+                      <m:e>
+                        <m:r>
+                          <a:rPr lang="en-US" b="0" i="1" smtClean="0">
+                            <a:latin typeface="Cambria Math" panose="02040503050406030204" pitchFamily="18" charset="0"/>
+                          </a:rPr>
+                          <m:t>𝜉</m:t>
+                        </m:r>
+                      </m:e>
+                      <m:sub>
+                        <m:r>
+                          <a:rPr lang="en-US" b="0" i="1" smtClean="0">
+                            <a:latin typeface="Cambria Math" panose="02040503050406030204" pitchFamily="18" charset="0"/>
+                          </a:rPr>
+                          <m:t>𝑘</m:t>
+                        </m:r>
+                      </m:sub>
+                    </m:sSub>
+                  </m:oMath>
+                </a14:m>
+                <a:r>
+                  <a:rPr lang="en-US" dirty="0"/>
+                  <a:t> die </a:t>
+                </a:r>
+                <a:r>
+                  <a:rPr lang="en-US" dirty="0" err="1"/>
+                  <a:t>Werte</a:t>
+                </a:r>
+                <a:r>
+                  <a:rPr lang="en-US" dirty="0"/>
+                  <a:t> </a:t>
+                </a:r>
+                <a14:m>
+                  <m:oMath xmlns:m="http://schemas.openxmlformats.org/officeDocument/2006/math">
+                    <m:r>
+                      <a:rPr lang="en-US" b="0" i="1" smtClean="0">
+                        <a:latin typeface="Cambria Math" panose="02040503050406030204" pitchFamily="18" charset="0"/>
+                      </a:rPr>
+                      <m:t>𝑧</m:t>
+                    </m:r>
+                  </m:oMath>
+                </a14:m>
+                <a:r>
+                  <a:rPr lang="en-US" dirty="0"/>
+                  <a:t> gemessen</a:t>
+                </a:r>
+              </a:p>
+              <a:p>
+                <a:r>
+                  <a:rPr lang="en-US" b="0" dirty="0"/>
+                  <a:t>Wir </a:t>
+                </a:r>
+                <a:r>
+                  <a:rPr lang="en-US" b="0" dirty="0" err="1"/>
+                  <a:t>berechnen</a:t>
+                </a:r>
+                <a:r>
+                  <a:rPr lang="en-US" b="0" dirty="0"/>
+                  <a:t>:		</a:t>
+                </a:r>
+                <a14:m>
+                  <m:oMath xmlns:m="http://schemas.openxmlformats.org/officeDocument/2006/math">
+                    <m:d>
+                      <m:dPr>
+                        <m:begChr m:val="["/>
+                        <m:endChr m:val="]"/>
+                        <m:ctrlPr>
+                          <a:rPr lang="en-US" i="1">
+                            <a:latin typeface="Cambria Math" panose="02040503050406030204" pitchFamily="18" charset="0"/>
+                          </a:rPr>
+                        </m:ctrlPr>
+                      </m:dPr>
+                      <m:e>
+                        <m:sSub>
+                          <m:sSubPr>
+                            <m:ctrlPr>
+                              <a:rPr lang="en-US" i="1">
+                                <a:latin typeface="Cambria Math" panose="02040503050406030204" pitchFamily="18" charset="0"/>
+                              </a:rPr>
+                            </m:ctrlPr>
+                          </m:sSubPr>
+                          <m:e>
+                            <m:r>
+                              <a:rPr lang="en-US" i="1">
+                                <a:latin typeface="Cambria Math" panose="02040503050406030204" pitchFamily="18" charset="0"/>
+                              </a:rPr>
+                              <m:t>𝜁</m:t>
+                            </m:r>
+                          </m:e>
+                          <m:sub>
+                            <m:r>
+                              <a:rPr lang="en-US" i="1">
+                                <a:latin typeface="Cambria Math" panose="02040503050406030204" pitchFamily="18" charset="0"/>
+                              </a:rPr>
+                              <m:t>𝑘</m:t>
+                            </m:r>
+                            <m:r>
+                              <a:rPr lang="en-US" i="1">
+                                <a:latin typeface="Cambria Math" panose="02040503050406030204" pitchFamily="18" charset="0"/>
+                              </a:rPr>
+                              <m:t>−</m:t>
+                            </m:r>
+                            <m:r>
+                              <a:rPr lang="en-US" i="1">
+                                <a:latin typeface="Cambria Math" panose="02040503050406030204" pitchFamily="18" charset="0"/>
+                              </a:rPr>
+                              <m:t>𝑛</m:t>
+                            </m:r>
+                          </m:sub>
+                        </m:sSub>
+                      </m:e>
+                    </m:d>
+                    <m:r>
+                      <a:rPr lang="en-US" b="0" i="1" smtClean="0">
+                        <a:latin typeface="Cambria Math" panose="02040503050406030204" pitchFamily="18" charset="0"/>
+                      </a:rPr>
+                      <m:t>=</m:t>
+                    </m:r>
+                    <m:sSubSup>
+                      <m:sSubSupPr>
+                        <m:ctrlPr>
+                          <a:rPr lang="en-US" b="0" i="1" smtClean="0">
+                            <a:latin typeface="Cambria Math" panose="02040503050406030204" pitchFamily="18" charset="0"/>
+                          </a:rPr>
+                        </m:ctrlPr>
+                      </m:sSubSupPr>
+                      <m:e>
+                        <m:r>
+                          <a:rPr lang="en-US" b="0" i="1" smtClean="0">
+                            <a:latin typeface="Cambria Math" panose="02040503050406030204" pitchFamily="18" charset="0"/>
+                          </a:rPr>
+                          <m:t>𝐹</m:t>
+                        </m:r>
+                      </m:e>
+                      <m:sub>
+                        <m:r>
+                          <a:rPr lang="en-US" b="0" i="1" smtClean="0">
+                            <a:latin typeface="Cambria Math" panose="02040503050406030204" pitchFamily="18" charset="0"/>
+                          </a:rPr>
+                          <m:t>2</m:t>
+                        </m:r>
+                        <m:r>
+                          <a:rPr lang="en-US" b="0" i="1" smtClean="0">
+                            <a:latin typeface="Cambria Math" panose="02040503050406030204" pitchFamily="18" charset="0"/>
+                          </a:rPr>
+                          <m:t>𝑛</m:t>
+                        </m:r>
+                        <m:r>
+                          <a:rPr lang="en-US" b="0" i="1" smtClean="0">
+                            <a:latin typeface="Cambria Math" panose="02040503050406030204" pitchFamily="18" charset="0"/>
+                          </a:rPr>
+                          <m:t>+2</m:t>
+                        </m:r>
+                      </m:sub>
+                      <m:sup>
+                        <m:r>
+                          <a:rPr lang="en-US" b="0" i="1" smtClean="0">
+                            <a:latin typeface="Cambria Math" panose="02040503050406030204" pitchFamily="18" charset="0"/>
+                          </a:rPr>
+                          <m:t>−1</m:t>
+                        </m:r>
+                      </m:sup>
+                    </m:sSubSup>
+                    <m:d>
+                      <m:dPr>
+                        <m:begChr m:val="["/>
+                        <m:endChr m:val="]"/>
+                        <m:ctrlPr>
+                          <a:rPr lang="en-US" b="0" i="1" smtClean="0">
+                            <a:latin typeface="Cambria Math" panose="02040503050406030204" pitchFamily="18" charset="0"/>
+                          </a:rPr>
+                        </m:ctrlPr>
+                      </m:dPr>
+                      <m:e>
+                        <m:func>
+                          <m:funcPr>
+                            <m:ctrlPr>
+                              <a:rPr lang="en-US" b="0" i="1" smtClean="0">
+                                <a:latin typeface="Cambria Math" panose="02040503050406030204" pitchFamily="18" charset="0"/>
+                              </a:rPr>
+                            </m:ctrlPr>
+                          </m:funcPr>
+                          <m:fName>
+                            <m:r>
+                              <m:rPr>
+                                <m:sty m:val="p"/>
+                              </m:rPr>
+                              <a:rPr lang="en-US" b="0" i="1" smtClean="0">
+                                <a:latin typeface="Cambria Math" panose="02040503050406030204" pitchFamily="18" charset="0"/>
+                              </a:rPr>
+                              <m:t>exp</m:t>
+                            </m:r>
+                          </m:fName>
+                          <m:e>
+                            <m:d>
+                              <m:dPr>
+                                <m:ctrlPr>
+                                  <a:rPr lang="en-US" b="0" i="1" smtClean="0">
+                                    <a:latin typeface="Cambria Math" panose="02040503050406030204" pitchFamily="18" charset="0"/>
+                                  </a:rPr>
+                                </m:ctrlPr>
+                              </m:dPr>
+                              <m:e>
+                                <m:f>
+                                  <m:fPr>
+                                    <m:ctrlPr>
+                                      <a:rPr lang="en-US" b="0" i="1" smtClean="0">
+                                        <a:latin typeface="Cambria Math" panose="02040503050406030204" pitchFamily="18" charset="0"/>
+                                      </a:rPr>
+                                    </m:ctrlPr>
+                                  </m:fPr>
+                                  <m:num>
+                                    <m:r>
+                                      <a:rPr lang="en-US" b="0" i="1" smtClean="0">
+                                        <a:latin typeface="Cambria Math" panose="02040503050406030204" pitchFamily="18" charset="0"/>
+                                      </a:rPr>
+                                      <m:t>𝜋</m:t>
+                                    </m:r>
+                                    <m:r>
+                                      <a:rPr lang="en-US" b="0" i="1" smtClean="0">
+                                        <a:latin typeface="Cambria Math" panose="02040503050406030204" pitchFamily="18" charset="0"/>
+                                      </a:rPr>
+                                      <m:t>𝑖𝑛</m:t>
+                                    </m:r>
+                                    <m:r>
+                                      <m:rPr>
+                                        <m:sty m:val="p"/>
+                                      </m:rPr>
+                                      <a:rPr lang="en-US" b="0" i="1" smtClean="0">
+                                        <a:latin typeface="Cambria Math" panose="02040503050406030204" pitchFamily="18" charset="0"/>
+                                      </a:rPr>
+                                      <m:t>ℓ</m:t>
+                                    </m:r>
+                                  </m:num>
+                                  <m:den>
+                                    <m:r>
+                                      <a:rPr lang="en-US" b="0" i="1" smtClean="0">
+                                        <a:latin typeface="Cambria Math" panose="02040503050406030204" pitchFamily="18" charset="0"/>
+                                      </a:rPr>
+                                      <m:t>𝑛</m:t>
+                                    </m:r>
+                                    <m:r>
+                                      <a:rPr lang="en-US" b="0" i="1" smtClean="0">
+                                        <a:latin typeface="Cambria Math" panose="02040503050406030204" pitchFamily="18" charset="0"/>
+                                      </a:rPr>
+                                      <m:t>+1</m:t>
+                                    </m:r>
+                                  </m:den>
+                                </m:f>
+                              </m:e>
+                            </m:d>
+                          </m:e>
+                        </m:func>
+                        <m:sSub>
+                          <m:sSubPr>
+                            <m:ctrlPr>
+                              <a:rPr lang="en-US" b="0" i="1" smtClean="0">
+                                <a:latin typeface="Cambria Math" panose="02040503050406030204" pitchFamily="18" charset="0"/>
+                              </a:rPr>
+                            </m:ctrlPr>
+                          </m:sSubPr>
+                          <m:e>
+                            <m:r>
+                              <a:rPr lang="en-US" b="0" i="1" smtClean="0">
+                                <a:latin typeface="Cambria Math" panose="02040503050406030204" pitchFamily="18" charset="0"/>
+                              </a:rPr>
+                              <m:t>𝑧</m:t>
+                            </m:r>
+                          </m:e>
+                          <m:sub>
+                            <m:r>
+                              <m:rPr>
+                                <m:sty m:val="p"/>
+                              </m:rPr>
+                              <a:rPr lang="en-US" b="0" i="1" smtClean="0">
+                                <a:latin typeface="Cambria Math" panose="02040503050406030204" pitchFamily="18" charset="0"/>
+                              </a:rPr>
+                              <m:t>ℓ</m:t>
+                            </m:r>
+                          </m:sub>
+                        </m:sSub>
+                      </m:e>
+                    </m:d>
+                  </m:oMath>
+                </a14:m>
+                <a:endParaRPr lang="en-US" dirty="0"/>
+              </a:p>
+              <a:p>
+                <a:r>
+                  <a:rPr lang="en-US" dirty="0" err="1"/>
+                  <a:t>Anhand</a:t>
+                </a:r>
+                <a:r>
+                  <a:rPr lang="en-US" dirty="0"/>
+                  <a:t> von:		</a:t>
+                </a:r>
+                <a14:m>
+                  <m:oMath xmlns:m="http://schemas.openxmlformats.org/officeDocument/2006/math">
+                    <m:sSub>
+                      <m:sSubPr>
+                        <m:ctrlPr>
+                          <a:rPr lang="en-US" b="0" i="1" smtClean="0">
+                            <a:latin typeface="Cambria Math" panose="02040503050406030204" pitchFamily="18" charset="0"/>
+                          </a:rPr>
+                        </m:ctrlPr>
+                      </m:sSubPr>
+                      <m:e>
+                        <m:r>
+                          <a:rPr lang="en-US" b="0" i="1" smtClean="0">
+                            <a:latin typeface="Cambria Math" panose="02040503050406030204" pitchFamily="18" charset="0"/>
+                          </a:rPr>
+                          <m:t>𝜁</m:t>
+                        </m:r>
+                      </m:e>
+                      <m:sub>
+                        <m:r>
+                          <a:rPr lang="en-US" b="0" i="1" smtClean="0">
+                            <a:latin typeface="Cambria Math" panose="02040503050406030204" pitchFamily="18" charset="0"/>
+                          </a:rPr>
+                          <m:t>𝑗</m:t>
+                        </m:r>
+                      </m:sub>
+                    </m:sSub>
+                    <m:r>
+                      <a:rPr lang="en-US" b="0" i="1" smtClean="0">
+                        <a:latin typeface="Cambria Math" panose="02040503050406030204" pitchFamily="18" charset="0"/>
+                      </a:rPr>
+                      <m:t>=</m:t>
+                    </m:r>
+                    <m:sSub>
+                      <m:sSubPr>
+                        <m:ctrlPr>
+                          <a:rPr lang="en-US" b="0" i="1" smtClean="0">
+                            <a:latin typeface="Cambria Math" panose="02040503050406030204" pitchFamily="18" charset="0"/>
+                          </a:rPr>
+                        </m:ctrlPr>
+                      </m:sSubPr>
+                      <m:e>
+                        <m:r>
+                          <a:rPr lang="en-US" b="0" i="1" smtClean="0">
+                            <a:latin typeface="Cambria Math" panose="02040503050406030204" pitchFamily="18" charset="0"/>
+                          </a:rPr>
+                          <m:t>𝑐</m:t>
+                        </m:r>
+                      </m:e>
+                      <m:sub>
+                        <m:r>
+                          <a:rPr lang="en-US" b="0" i="1" smtClean="0">
+                            <a:latin typeface="Cambria Math" panose="02040503050406030204" pitchFamily="18" charset="0"/>
+                          </a:rPr>
+                          <m:t>𝑗</m:t>
+                        </m:r>
+                      </m:sub>
+                    </m:sSub>
+                    <m:func>
+                      <m:funcPr>
+                        <m:ctrlPr>
+                          <a:rPr lang="en-US" b="0" i="1" smtClean="0">
+                            <a:latin typeface="Cambria Math" panose="02040503050406030204" pitchFamily="18" charset="0"/>
+                          </a:rPr>
+                        </m:ctrlPr>
+                      </m:funcPr>
+                      <m:fName>
+                        <m:r>
+                          <m:rPr>
+                            <m:sty m:val="p"/>
+                          </m:rPr>
+                          <a:rPr lang="en-US" b="0" i="1" smtClean="0">
+                            <a:latin typeface="Cambria Math" panose="02040503050406030204" pitchFamily="18" charset="0"/>
+                          </a:rPr>
+                          <m:t>exp</m:t>
+                        </m:r>
+                      </m:fName>
+                      <m:e>
+                        <m:d>
+                          <m:dPr>
+                            <m:ctrlPr>
+                              <a:rPr lang="en-US" b="0" i="1" smtClean="0">
+                                <a:latin typeface="Cambria Math" panose="02040503050406030204" pitchFamily="18" charset="0"/>
+                              </a:rPr>
+                            </m:ctrlPr>
+                          </m:dPr>
+                          <m:e>
+                            <m:f>
+                              <m:fPr>
+                                <m:ctrlPr>
+                                  <a:rPr lang="en-US" b="0" i="1" smtClean="0">
+                                    <a:latin typeface="Cambria Math" panose="02040503050406030204" pitchFamily="18" charset="0"/>
+                                  </a:rPr>
+                                </m:ctrlPr>
+                              </m:fPr>
+                              <m:num>
+                                <m:r>
+                                  <a:rPr lang="en-US" b="0" i="1" smtClean="0">
+                                    <a:latin typeface="Cambria Math" panose="02040503050406030204" pitchFamily="18" charset="0"/>
+                                  </a:rPr>
+                                  <m:t>2</m:t>
+                                </m:r>
+                                <m:r>
+                                  <a:rPr lang="en-US" b="0" i="1" smtClean="0">
+                                    <a:latin typeface="Cambria Math" panose="02040503050406030204" pitchFamily="18" charset="0"/>
+                                  </a:rPr>
+                                  <m:t>𝜋</m:t>
+                                </m:r>
+                                <m:r>
+                                  <a:rPr lang="en-US" b="0" i="1" smtClean="0">
+                                    <a:latin typeface="Cambria Math" panose="02040503050406030204" pitchFamily="18" charset="0"/>
+                                  </a:rPr>
+                                  <m:t>𝑖𝑗</m:t>
+                                </m:r>
+                              </m:num>
+                              <m:den>
+                                <m:r>
+                                  <a:rPr lang="en-US" b="0" i="1" smtClean="0">
+                                    <a:latin typeface="Cambria Math" panose="02040503050406030204" pitchFamily="18" charset="0"/>
+                                  </a:rPr>
+                                  <m:t>4</m:t>
+                                </m:r>
+                                <m:d>
+                                  <m:dPr>
+                                    <m:ctrlPr>
+                                      <a:rPr lang="en-US" b="0" i="1" smtClean="0">
+                                        <a:latin typeface="Cambria Math" panose="02040503050406030204" pitchFamily="18" charset="0"/>
+                                      </a:rPr>
+                                    </m:ctrlPr>
+                                  </m:dPr>
+                                  <m:e>
+                                    <m:r>
+                                      <a:rPr lang="en-US" b="0" i="1" smtClean="0">
+                                        <a:latin typeface="Cambria Math" panose="02040503050406030204" pitchFamily="18" charset="0"/>
+                                      </a:rPr>
+                                      <m:t>𝑛</m:t>
+                                    </m:r>
+                                    <m:r>
+                                      <a:rPr lang="en-US" b="0" i="1" smtClean="0">
+                                        <a:latin typeface="Cambria Math" panose="02040503050406030204" pitchFamily="18" charset="0"/>
+                                      </a:rPr>
+                                      <m:t>+1</m:t>
+                                    </m:r>
+                                  </m:e>
+                                </m:d>
+                              </m:den>
+                            </m:f>
+                          </m:e>
+                        </m:d>
+                      </m:e>
+                    </m:func>
+                  </m:oMath>
+                </a14:m>
+                <a:r>
+                  <a:rPr lang="en-US" dirty="0"/>
+                  <a:t> 		</a:t>
+                </a:r>
+                <a:r>
+                  <a:rPr lang="en-US" dirty="0" err="1"/>
+                  <a:t>extrahieren</a:t>
+                </a:r>
+                <a:r>
+                  <a:rPr lang="en-US" dirty="0"/>
+                  <a:t> </a:t>
+                </a:r>
+                <a:r>
+                  <a:rPr lang="en-US" dirty="0" err="1"/>
+                  <a:t>wir</a:t>
+                </a:r>
+                <a:r>
+                  <a:rPr lang="en-US" dirty="0"/>
+                  <a:t> </a:t>
+                </a:r>
+                <a14:m>
+                  <m:oMath xmlns:m="http://schemas.openxmlformats.org/officeDocument/2006/math">
+                    <m:sSub>
+                      <m:sSubPr>
+                        <m:ctrlPr>
+                          <a:rPr lang="en-US" b="0" i="1" smtClean="0">
+                            <a:latin typeface="Cambria Math" panose="02040503050406030204" pitchFamily="18" charset="0"/>
+                          </a:rPr>
+                        </m:ctrlPr>
+                      </m:sSubPr>
+                      <m:e>
+                        <m:r>
+                          <a:rPr lang="en-US" b="0" i="1" smtClean="0">
+                            <a:latin typeface="Cambria Math" panose="02040503050406030204" pitchFamily="18" charset="0"/>
+                          </a:rPr>
+                          <m:t>𝑐</m:t>
+                        </m:r>
+                      </m:e>
+                      <m:sub>
+                        <m:r>
+                          <a:rPr lang="en-US" b="0" i="1" smtClean="0">
+                            <a:latin typeface="Cambria Math" panose="02040503050406030204" pitchFamily="18" charset="0"/>
+                          </a:rPr>
+                          <m:t>𝑗</m:t>
+                        </m:r>
+                      </m:sub>
+                    </m:sSub>
+                  </m:oMath>
+                </a14:m>
+                <a:endParaRPr lang="en-US" dirty="0"/>
+              </a:p>
+              <a:p>
+                <a:r>
+                  <a:rPr lang="en-US" dirty="0"/>
+                  <a:t>Wir </a:t>
+                </a:r>
+                <a:r>
+                  <a:rPr lang="en-US" dirty="0" err="1"/>
+                  <a:t>extrahieren</a:t>
+                </a:r>
+                <a:r>
+                  <a:rPr lang="en-US" dirty="0"/>
+                  <a:t> </a:t>
+                </a:r>
+                <a14:m>
+                  <m:oMath xmlns:m="http://schemas.openxmlformats.org/officeDocument/2006/math">
+                    <m:sSub>
+                      <m:sSubPr>
+                        <m:ctrlPr>
+                          <a:rPr lang="en-US" b="0" i="1" smtClean="0">
+                            <a:latin typeface="Cambria Math" panose="02040503050406030204" pitchFamily="18" charset="0"/>
+                          </a:rPr>
+                        </m:ctrlPr>
+                      </m:sSubPr>
+                      <m:e>
+                        <m:r>
+                          <a:rPr lang="en-US" b="0" i="1" smtClean="0">
+                            <a:latin typeface="Cambria Math" panose="02040503050406030204" pitchFamily="18" charset="0"/>
+                          </a:rPr>
+                          <m:t>𝑎</m:t>
+                        </m:r>
+                      </m:e>
+                      <m:sub>
+                        <m:r>
+                          <a:rPr lang="en-US" b="0" i="1" smtClean="0">
+                            <a:latin typeface="Cambria Math" panose="02040503050406030204" pitchFamily="18" charset="0"/>
+                          </a:rPr>
+                          <m:t>𝑗</m:t>
+                        </m:r>
+                      </m:sub>
+                    </m:sSub>
+                  </m:oMath>
+                </a14:m>
+                <a:r>
+                  <a:rPr lang="en-US" dirty="0"/>
+                  <a:t> </a:t>
+                </a:r>
+                <a:r>
+                  <a:rPr lang="en-US" dirty="0" err="1"/>
+                  <a:t>aus</a:t>
+                </a:r>
+                <a:r>
+                  <a:rPr lang="en-US" dirty="0"/>
+                  <a:t> </a:t>
+                </a:r>
+                <a14:m>
+                  <m:oMath xmlns:m="http://schemas.openxmlformats.org/officeDocument/2006/math">
+                    <m:sSub>
+                      <m:sSubPr>
+                        <m:ctrlPr>
+                          <a:rPr lang="en-US" b="0" i="1" smtClean="0">
+                            <a:latin typeface="Cambria Math" panose="02040503050406030204" pitchFamily="18" charset="0"/>
+                          </a:rPr>
+                        </m:ctrlPr>
+                      </m:sSubPr>
+                      <m:e>
+                        <m:r>
+                          <a:rPr lang="en-US" b="0" i="1" smtClean="0">
+                            <a:latin typeface="Cambria Math" panose="02040503050406030204" pitchFamily="18" charset="0"/>
+                          </a:rPr>
+                          <m:t>𝑐</m:t>
+                        </m:r>
+                      </m:e>
+                      <m:sub>
+                        <m:r>
+                          <a:rPr lang="en-US" b="0" i="1" smtClean="0">
+                            <a:latin typeface="Cambria Math" panose="02040503050406030204" pitchFamily="18" charset="0"/>
+                          </a:rPr>
+                          <m:t>𝑗</m:t>
+                        </m:r>
+                      </m:sub>
+                    </m:sSub>
+                  </m:oMath>
+                </a14:m>
+                <a:r>
+                  <a:rPr lang="en-US" dirty="0"/>
+                  <a:t> </a:t>
+                </a:r>
+                <a:r>
+                  <a:rPr lang="en-US" dirty="0" err="1"/>
+                  <a:t>mit</a:t>
+                </a:r>
+                <a:r>
+                  <a:rPr lang="en-US" dirty="0"/>
+                  <a:t>:</a:t>
+                </a:r>
+              </a:p>
+              <a:p>
+                <a:pPr marL="0" indent="0">
+                  <a:buNone/>
+                </a:pPr>
+                <a14:m>
+                  <m:oMathPara xmlns:m="http://schemas.openxmlformats.org/officeDocument/2006/math">
+                    <m:oMath>
+                      <m:sSub>
+                        <m:sSubPr>
+                          <m:ctrlPr>
+                            <a:rPr lang="en-US" b="0" i="1" smtClean="0">
+                              <a:latin typeface="Cambria Math" panose="02040503050406030204" pitchFamily="18" charset="0"/>
+                            </a:rPr>
+                          </m:ctrlPr>
+                        </m:sSubPr>
+                        <m:e>
+                          <m:r>
+                            <a:rPr lang="en-US" b="0" i="1" smtClean="0">
+                              <a:latin typeface="Cambria Math" panose="02040503050406030204" pitchFamily="18" charset="0"/>
+                            </a:rPr>
+                            <m:t>𝑐</m:t>
+                          </m:r>
+                        </m:e>
+                        <m:sub>
+                          <m:r>
+                            <a:rPr lang="en-US" b="0" i="1" smtClean="0">
+                              <a:latin typeface="Cambria Math" panose="02040503050406030204" pitchFamily="18" charset="0"/>
+                            </a:rPr>
+                            <m:t>𝑗</m:t>
+                          </m:r>
+                        </m:sub>
+                      </m:sSub>
+                      <m:r>
+                        <a:rPr lang="en-US" b="0" i="1" smtClean="0">
+                          <a:latin typeface="Cambria Math" panose="02040503050406030204" pitchFamily="18" charset="0"/>
+                        </a:rPr>
+                        <m:t>=</m:t>
+                      </m:r>
+                      <m:d>
+                        <m:dPr>
+                          <m:begChr m:val="{"/>
+                          <m:endChr m:val=""/>
+                          <m:ctrlPr>
+                            <a:rPr lang="en-US" b="0" i="1" smtClean="0">
+                              <a:latin typeface="Cambria Math" panose="02040503050406030204" pitchFamily="18" charset="0"/>
+                            </a:rPr>
+                          </m:ctrlPr>
+                        </m:dPr>
+                        <m:e>
+                          <m:m>
+                            <m:mPr>
+                              <m:mcs>
+                                <m:mc>
+                                  <m:mcPr>
+                                    <m:count m:val="2"/>
+                                    <m:mcJc m:val="center"/>
+                                  </m:mcPr>
+                                </m:mc>
+                              </m:mcs>
+                              <m:ctrlPr>
+                                <a:rPr lang="en-US" b="0" i="1" smtClean="0">
+                                  <a:latin typeface="Cambria Math" panose="02040503050406030204" pitchFamily="18" charset="0"/>
+                                </a:rPr>
+                              </m:ctrlPr>
+                            </m:mPr>
+                            <m:mr>
+                              <m:e>
+                                <m:f>
+                                  <m:fPr>
+                                    <m:ctrlPr>
+                                      <a:rPr lang="en-US" b="0" i="1" smtClean="0">
+                                        <a:latin typeface="Cambria Math" panose="02040503050406030204" pitchFamily="18" charset="0"/>
+                                      </a:rPr>
+                                    </m:ctrlPr>
+                                  </m:fPr>
+                                  <m:num>
+                                    <m:r>
+                                      <a:rPr lang="en-US" b="0" i="1" smtClean="0">
+                                        <a:latin typeface="Cambria Math" panose="02040503050406030204" pitchFamily="18" charset="0"/>
+                                      </a:rPr>
+                                      <m:t>1</m:t>
+                                    </m:r>
+                                  </m:num>
+                                  <m:den>
+                                    <m:r>
+                                      <a:rPr lang="en-US" b="0" i="1" smtClean="0">
+                                        <a:latin typeface="Cambria Math" panose="02040503050406030204" pitchFamily="18" charset="0"/>
+                                      </a:rPr>
+                                      <m:t>2</m:t>
+                                    </m:r>
+                                  </m:den>
+                                </m:f>
+                                <m:sSub>
+                                  <m:sSubPr>
+                                    <m:ctrlPr>
+                                      <a:rPr lang="en-US" b="0" i="1" smtClean="0">
+                                        <a:latin typeface="Cambria Math" panose="02040503050406030204" pitchFamily="18" charset="0"/>
+                                      </a:rPr>
+                                    </m:ctrlPr>
+                                  </m:sSubPr>
+                                  <m:e>
+                                    <m:r>
+                                      <a:rPr lang="en-US" b="0" i="1" smtClean="0">
+                                        <a:latin typeface="Cambria Math" panose="02040503050406030204" pitchFamily="18" charset="0"/>
+                                      </a:rPr>
+                                      <m:t>𝑎</m:t>
+                                    </m:r>
+                                  </m:e>
+                                  <m:sub>
+                                    <m:r>
+                                      <a:rPr lang="en-US" b="0" i="1" smtClean="0">
+                                        <a:latin typeface="Cambria Math" panose="02040503050406030204" pitchFamily="18" charset="0"/>
+                                      </a:rPr>
+                                      <m:t>𝑗</m:t>
+                                    </m:r>
+                                  </m:sub>
+                                </m:sSub>
+                              </m:e>
+                              <m:e>
+                                <m:r>
+                                  <m:rPr>
+                                    <m:sty m:val="p"/>
+                                  </m:rPr>
+                                  <a:rPr lang="en-US" b="0" i="1" smtClean="0">
+                                    <a:latin typeface="Cambria Math" panose="02040503050406030204" pitchFamily="18" charset="0"/>
+                                  </a:rPr>
+                                  <m:t>f</m:t>
+                                </m:r>
+                                <m:r>
+                                  <a:rPr lang="en-US" b="0" i="1" smtClean="0">
+                                    <a:latin typeface="Cambria Math" panose="02040503050406030204" pitchFamily="18" charset="0"/>
+                                  </a:rPr>
+                                  <m:t>ü</m:t>
+                                </m:r>
+                                <m:r>
+                                  <m:rPr>
+                                    <m:sty m:val="p"/>
+                                  </m:rPr>
+                                  <a:rPr lang="en-US" b="0" i="1" smtClean="0">
+                                    <a:latin typeface="Cambria Math" panose="02040503050406030204" pitchFamily="18" charset="0"/>
+                                  </a:rPr>
+                                  <m:t>r</m:t>
+                                </m:r>
+                                <m:r>
+                                  <a:rPr lang="en-US" b="0" i="1" smtClean="0">
+                                    <a:latin typeface="Cambria Math" panose="02040503050406030204" pitchFamily="18" charset="0"/>
+                                  </a:rPr>
+                                  <m:t>: </m:t>
+                                </m:r>
+                                <m:r>
+                                  <a:rPr lang="en-US" b="0" i="1" smtClean="0">
+                                    <a:latin typeface="Cambria Math" panose="02040503050406030204" pitchFamily="18" charset="0"/>
+                                  </a:rPr>
+                                  <m:t>𝑗</m:t>
+                                </m:r>
+                                <m:r>
+                                  <a:rPr lang="en-US" b="0" i="1" smtClean="0">
+                                    <a:latin typeface="Cambria Math" panose="02040503050406030204" pitchFamily="18" charset="0"/>
+                                  </a:rPr>
+                                  <m:t>=1,...,</m:t>
+                                </m:r>
+                                <m:r>
+                                  <a:rPr lang="en-US" b="0" i="1" smtClean="0">
+                                    <a:latin typeface="Cambria Math" panose="02040503050406030204" pitchFamily="18" charset="0"/>
+                                  </a:rPr>
+                                  <m:t>𝑛</m:t>
+                                </m:r>
+                              </m:e>
+                            </m:mr>
+                            <m:mr>
+                              <m:e>
+                                <m:sSub>
+                                  <m:sSubPr>
+                                    <m:ctrlPr>
+                                      <a:rPr lang="en-US" b="0" i="1" smtClean="0">
+                                        <a:latin typeface="Cambria Math" panose="02040503050406030204" pitchFamily="18" charset="0"/>
+                                      </a:rPr>
+                                    </m:ctrlPr>
+                                  </m:sSubPr>
+                                  <m:e>
+                                    <m:r>
+                                      <a:rPr lang="en-US" b="0" i="1" smtClean="0">
+                                        <a:latin typeface="Cambria Math" panose="02040503050406030204" pitchFamily="18" charset="0"/>
+                                      </a:rPr>
+                                      <m:t>𝑎</m:t>
+                                    </m:r>
+                                  </m:e>
+                                  <m:sub>
+                                    <m:r>
+                                      <a:rPr lang="en-US" b="0" i="1" smtClean="0">
+                                        <a:latin typeface="Cambria Math" panose="02040503050406030204" pitchFamily="18" charset="0"/>
+                                      </a:rPr>
+                                      <m:t>0</m:t>
+                                    </m:r>
+                                  </m:sub>
+                                </m:sSub>
+                              </m:e>
+                              <m:e>
+                                <m:r>
+                                  <m:rPr>
+                                    <m:sty m:val="p"/>
+                                  </m:rPr>
+                                  <a:rPr lang="en-US" b="0" i="1" smtClean="0">
+                                    <a:latin typeface="Cambria Math" panose="02040503050406030204" pitchFamily="18" charset="0"/>
+                                  </a:rPr>
+                                  <m:t>f</m:t>
+                                </m:r>
+                                <m:r>
+                                  <a:rPr lang="en-US" b="0" i="1" smtClean="0">
+                                    <a:latin typeface="Cambria Math" panose="02040503050406030204" pitchFamily="18" charset="0"/>
+                                  </a:rPr>
+                                  <m:t>ü</m:t>
+                                </m:r>
+                                <m:r>
+                                  <m:rPr>
+                                    <m:sty m:val="p"/>
+                                  </m:rPr>
+                                  <a:rPr lang="en-US" b="0" i="1" smtClean="0">
+                                    <a:latin typeface="Cambria Math" panose="02040503050406030204" pitchFamily="18" charset="0"/>
+                                  </a:rPr>
+                                  <m:t>r</m:t>
+                                </m:r>
+                                <m:r>
+                                  <a:rPr lang="en-US" b="0" i="1" smtClean="0">
+                                    <a:latin typeface="Cambria Math" panose="02040503050406030204" pitchFamily="18" charset="0"/>
+                                  </a:rPr>
+                                  <m:t>: </m:t>
+                                </m:r>
+                                <m:r>
+                                  <a:rPr lang="en-US" b="0" i="1" smtClean="0">
+                                    <a:latin typeface="Cambria Math" panose="02040503050406030204" pitchFamily="18" charset="0"/>
+                                  </a:rPr>
+                                  <m:t>𝑗</m:t>
+                                </m:r>
+                                <m:r>
+                                  <a:rPr lang="en-US" b="0" i="1" smtClean="0">
+                                    <a:latin typeface="Cambria Math" panose="02040503050406030204" pitchFamily="18" charset="0"/>
+                                  </a:rPr>
+                                  <m:t>=0</m:t>
+                                </m:r>
+                              </m:e>
+                            </m:mr>
+                            <m:mr>
+                              <m:e>
+                                <m:f>
+                                  <m:fPr>
+                                    <m:ctrlPr>
+                                      <a:rPr lang="en-US" b="0" i="1" smtClean="0">
+                                        <a:latin typeface="Cambria Math" panose="02040503050406030204" pitchFamily="18" charset="0"/>
+                                      </a:rPr>
+                                    </m:ctrlPr>
+                                  </m:fPr>
+                                  <m:num>
+                                    <m:r>
+                                      <a:rPr lang="en-US" b="0" i="1" smtClean="0">
+                                        <a:latin typeface="Cambria Math" panose="02040503050406030204" pitchFamily="18" charset="0"/>
+                                      </a:rPr>
+                                      <m:t>1</m:t>
+                                    </m:r>
+                                  </m:num>
+                                  <m:den>
+                                    <m:r>
+                                      <a:rPr lang="en-US" b="0" i="1" smtClean="0">
+                                        <a:latin typeface="Cambria Math" panose="02040503050406030204" pitchFamily="18" charset="0"/>
+                                      </a:rPr>
+                                      <m:t>2</m:t>
+                                    </m:r>
+                                  </m:den>
+                                </m:f>
+                                <m:sSub>
+                                  <m:sSubPr>
+                                    <m:ctrlPr>
+                                      <a:rPr lang="en-US" b="0" i="1" smtClean="0">
+                                        <a:latin typeface="Cambria Math" panose="02040503050406030204" pitchFamily="18" charset="0"/>
+                                      </a:rPr>
+                                    </m:ctrlPr>
+                                  </m:sSubPr>
+                                  <m:e>
+                                    <m:r>
+                                      <a:rPr lang="en-US" b="0" i="1" smtClean="0">
+                                        <a:latin typeface="Cambria Math" panose="02040503050406030204" pitchFamily="18" charset="0"/>
+                                      </a:rPr>
+                                      <m:t>𝑎</m:t>
+                                    </m:r>
+                                  </m:e>
+                                  <m:sub>
+                                    <m:r>
+                                      <a:rPr lang="en-US" b="0" i="1" smtClean="0">
+                                        <a:latin typeface="Cambria Math" panose="02040503050406030204" pitchFamily="18" charset="0"/>
+                                      </a:rPr>
+                                      <m:t>−</m:t>
+                                    </m:r>
+                                    <m:r>
+                                      <a:rPr lang="en-US" b="0" i="1" smtClean="0">
+                                        <a:latin typeface="Cambria Math" panose="02040503050406030204" pitchFamily="18" charset="0"/>
+                                      </a:rPr>
+                                      <m:t>𝑗</m:t>
+                                    </m:r>
+                                  </m:sub>
+                                </m:sSub>
+                              </m:e>
+                              <m:e>
+                                <m:r>
+                                  <m:rPr>
+                                    <m:sty m:val="p"/>
+                                  </m:rPr>
+                                  <a:rPr lang="en-US" b="0" i="1" smtClean="0">
+                                    <a:latin typeface="Cambria Math" panose="02040503050406030204" pitchFamily="18" charset="0"/>
+                                  </a:rPr>
+                                  <m:t>f</m:t>
+                                </m:r>
+                                <m:r>
+                                  <a:rPr lang="en-US" b="0" i="1" smtClean="0">
+                                    <a:latin typeface="Cambria Math" panose="02040503050406030204" pitchFamily="18" charset="0"/>
+                                  </a:rPr>
+                                  <m:t>ü</m:t>
+                                </m:r>
+                                <m:r>
+                                  <m:rPr>
+                                    <m:sty m:val="p"/>
+                                  </m:rPr>
+                                  <a:rPr lang="en-US" b="0" i="1" smtClean="0">
+                                    <a:latin typeface="Cambria Math" panose="02040503050406030204" pitchFamily="18" charset="0"/>
+                                  </a:rPr>
+                                  <m:t>r</m:t>
+                                </m:r>
+                                <m:r>
+                                  <a:rPr lang="en-US" b="0" i="1" smtClean="0">
+                                    <a:latin typeface="Cambria Math" panose="02040503050406030204" pitchFamily="18" charset="0"/>
+                                  </a:rPr>
+                                  <m:t>: </m:t>
+                                </m:r>
+                                <m:r>
+                                  <a:rPr lang="en-US" b="0" i="1" smtClean="0">
+                                    <a:latin typeface="Cambria Math" panose="02040503050406030204" pitchFamily="18" charset="0"/>
+                                  </a:rPr>
+                                  <m:t>𝑗</m:t>
+                                </m:r>
+                                <m:r>
+                                  <a:rPr lang="en-US" b="0" i="1" smtClean="0">
+                                    <a:latin typeface="Cambria Math" panose="02040503050406030204" pitchFamily="18" charset="0"/>
+                                  </a:rPr>
+                                  <m:t>=−</m:t>
+                                </m:r>
+                                <m:r>
+                                  <a:rPr lang="en-US" b="0" i="1" smtClean="0">
+                                    <a:latin typeface="Cambria Math" panose="02040503050406030204" pitchFamily="18" charset="0"/>
+                                  </a:rPr>
+                                  <m:t>𝑛</m:t>
+                                </m:r>
+                                <m:r>
+                                  <a:rPr lang="en-US" b="0" i="1" smtClean="0">
+                                    <a:latin typeface="Cambria Math" panose="02040503050406030204" pitchFamily="18" charset="0"/>
+                                  </a:rPr>
+                                  <m:t>,...,−1</m:t>
+                                </m:r>
+                              </m:e>
+                            </m:mr>
+                          </m:m>
+                        </m:e>
+                      </m:d>
+                    </m:oMath>
+                  </m:oMathPara>
+                </a14:m>
+                <a:endParaRPr lang="en-US" dirty="0"/>
+              </a:p>
+              <a:p>
+                <a14:m>
+                  <m:oMath xmlns:m="http://schemas.openxmlformats.org/officeDocument/2006/math">
+                    <m:acc>
+                      <m:accPr>
+                        <m:chr m:val="˜"/>
+                        <m:ctrlPr>
+                          <a:rPr lang="en-US" b="0" i="1" smtClean="0">
+                            <a:latin typeface="Cambria Math" panose="02040503050406030204" pitchFamily="18" charset="0"/>
+                          </a:rPr>
+                        </m:ctrlPr>
+                      </m:accPr>
+                      <m:e>
+                        <m:r>
+                          <a:rPr lang="en-US" b="0" i="1" smtClean="0">
+                            <a:latin typeface="Cambria Math" panose="02040503050406030204" pitchFamily="18" charset="0"/>
+                          </a:rPr>
+                          <m:t>𝑓</m:t>
+                        </m:r>
+                      </m:e>
+                    </m:acc>
+                    <m:d>
+                      <m:dPr>
+                        <m:ctrlPr>
+                          <a:rPr lang="en-US" b="0" i="1" smtClean="0">
+                            <a:latin typeface="Cambria Math" panose="02040503050406030204" pitchFamily="18" charset="0"/>
+                          </a:rPr>
+                        </m:ctrlPr>
+                      </m:dPr>
+                      <m:e>
+                        <m:r>
+                          <a:rPr lang="en-US" b="0" i="1" smtClean="0">
+                            <a:latin typeface="Cambria Math" panose="02040503050406030204" pitchFamily="18" charset="0"/>
+                          </a:rPr>
+                          <m:t>𝑡</m:t>
+                        </m:r>
+                      </m:e>
+                    </m:d>
+                    <m:r>
+                      <a:rPr lang="en-US" b="0" i="1" smtClean="0">
+                        <a:latin typeface="Cambria Math" panose="02040503050406030204" pitchFamily="18" charset="0"/>
+                      </a:rPr>
+                      <m:t>=</m:t>
+                    </m:r>
+                    <m:nary>
+                      <m:naryPr>
+                        <m:chr m:val="∑"/>
+                        <m:limLoc m:val="undOvr"/>
+                        <m:ctrlPr>
+                          <a:rPr lang="en-US" b="0" i="1" smtClean="0">
+                            <a:latin typeface="Cambria Math" panose="02040503050406030204" pitchFamily="18" charset="0"/>
+                          </a:rPr>
+                        </m:ctrlPr>
+                      </m:naryPr>
+                      <m:sub>
+                        <m:r>
+                          <a:rPr lang="en-US" b="0" i="1" smtClean="0">
+                            <a:latin typeface="Cambria Math" panose="02040503050406030204" pitchFamily="18" charset="0"/>
+                          </a:rPr>
+                          <m:t>𝑗</m:t>
+                        </m:r>
+                        <m:r>
+                          <a:rPr lang="en-US" b="0" i="1" smtClean="0">
+                            <a:latin typeface="Cambria Math" panose="02040503050406030204" pitchFamily="18" charset="0"/>
+                          </a:rPr>
+                          <m:t>=0</m:t>
+                        </m:r>
+                      </m:sub>
+                      <m:sup>
+                        <m:r>
+                          <a:rPr lang="en-US" b="0" i="1" smtClean="0">
+                            <a:latin typeface="Cambria Math" panose="02040503050406030204" pitchFamily="18" charset="0"/>
+                          </a:rPr>
+                          <m:t>𝑛</m:t>
+                        </m:r>
+                      </m:sup>
+                      <m:e>
+                        <m:sSub>
+                          <m:sSubPr>
+                            <m:ctrlPr>
+                              <a:rPr lang="en-US" b="0" i="1" smtClean="0">
+                                <a:latin typeface="Cambria Math" panose="02040503050406030204" pitchFamily="18" charset="0"/>
+                              </a:rPr>
+                            </m:ctrlPr>
+                          </m:sSubPr>
+                          <m:e>
+                            <m:r>
+                              <a:rPr lang="en-US" b="0" i="1" smtClean="0">
+                                <a:latin typeface="Cambria Math" panose="02040503050406030204" pitchFamily="18" charset="0"/>
+                              </a:rPr>
+                              <m:t>𝑎</m:t>
+                            </m:r>
+                          </m:e>
+                          <m:sub>
+                            <m:r>
+                              <a:rPr lang="en-US" b="0" i="1" smtClean="0">
+                                <a:latin typeface="Cambria Math" panose="02040503050406030204" pitchFamily="18" charset="0"/>
+                              </a:rPr>
+                              <m:t>𝑗</m:t>
+                            </m:r>
+                          </m:sub>
+                        </m:sSub>
+                        <m:sSub>
+                          <m:sSubPr>
+                            <m:ctrlPr>
+                              <a:rPr lang="en-US" b="0" i="1" smtClean="0">
+                                <a:latin typeface="Cambria Math" panose="02040503050406030204" pitchFamily="18" charset="0"/>
+                              </a:rPr>
+                            </m:ctrlPr>
+                          </m:sSubPr>
+                          <m:e>
+                            <m:r>
+                              <a:rPr lang="en-US" b="0" i="1" smtClean="0">
+                                <a:latin typeface="Cambria Math" panose="02040503050406030204" pitchFamily="18" charset="0"/>
+                              </a:rPr>
+                              <m:t>𝑇</m:t>
+                            </m:r>
+                          </m:e>
+                          <m:sub>
+                            <m:r>
+                              <a:rPr lang="en-US" b="0" i="1" smtClean="0">
+                                <a:latin typeface="Cambria Math" panose="02040503050406030204" pitchFamily="18" charset="0"/>
+                              </a:rPr>
+                              <m:t>𝑗</m:t>
+                            </m:r>
+                          </m:sub>
+                        </m:sSub>
+                        <m:d>
+                          <m:dPr>
+                            <m:ctrlPr>
+                              <a:rPr lang="en-US" b="0" i="1" smtClean="0">
+                                <a:latin typeface="Cambria Math" panose="02040503050406030204" pitchFamily="18" charset="0"/>
+                              </a:rPr>
+                            </m:ctrlPr>
+                          </m:dPr>
+                          <m:e>
+                            <m:r>
+                              <a:rPr lang="en-US" b="0" i="1" smtClean="0">
+                                <a:latin typeface="Cambria Math" panose="02040503050406030204" pitchFamily="18" charset="0"/>
+                              </a:rPr>
+                              <m:t>𝑡</m:t>
+                            </m:r>
+                          </m:e>
+                        </m:d>
+                      </m:e>
+                    </m:nary>
+                  </m:oMath>
+                </a14:m>
+                <a:endParaRPr lang="en-CH" dirty="0"/>
+              </a:p>
+            </p:txBody>
+          </p:sp>
+        </mc:Choice>
+        <mc:Fallback>
+          <p:sp>
+            <p:nvSpPr>
+              <p:cNvPr id="3" name="Content Placeholder 2">
+                <a:extLst>
+                  <a:ext uri="{FF2B5EF4-FFF2-40B4-BE49-F238E27FC236}">
+                    <a16:creationId xmlns:a16="http://schemas.microsoft.com/office/drawing/2014/main" id="{288B89D9-43D9-95E7-21F3-7D737FDB0F6F}"/>
+                  </a:ext>
+                </a:extLst>
+              </p:cNvPr>
+              <p:cNvSpPr>
+                <a:spLocks noGrp="1" noRot="1" noChangeAspect="1" noMove="1" noResize="1" noEditPoints="1" noAdjustHandles="1" noChangeArrowheads="1" noChangeShapeType="1" noTextEdit="1"/>
+              </p:cNvSpPr>
+              <p:nvPr>
+                <p:ph idx="1"/>
+              </p:nvPr>
+            </p:nvSpPr>
+            <p:spPr>
+              <a:blipFill>
+                <a:blip r:embed="rId2"/>
+                <a:stretch>
+                  <a:fillRect l="-1193" t="-1695" b="-2608"/>
+                </a:stretch>
+              </a:blipFill>
+            </p:spPr>
+            <p:txBody>
+              <a:bodyPr/>
+              <a:lstStyle/>
+              <a:p>
+                <a:r>
+                  <a:rPr lang="en-CH">
+                    <a:noFill/>
+                  </a:rPr>
+                  <a:t> </a:t>
+                </a:r>
+              </a:p>
+            </p:txBody>
+          </p:sp>
+        </mc:Fallback>
+      </mc:AlternateContent>
+      <p:sp>
+        <p:nvSpPr>
+          <p:cNvPr id="4" name="Date Placeholder 3">
+            <a:extLst>
+              <a:ext uri="{FF2B5EF4-FFF2-40B4-BE49-F238E27FC236}">
+                <a16:creationId xmlns:a16="http://schemas.microsoft.com/office/drawing/2014/main" id="{D12EB180-8C85-4B58-E556-3D6C3EF13643}"/>
+              </a:ext>
+            </a:extLst>
+          </p:cNvPr>
+          <p:cNvSpPr>
+            <a:spLocks noGrp="1"/>
+          </p:cNvSpPr>
+          <p:nvPr>
+            <p:ph type="dt" sz="half" idx="10"/>
+          </p:nvPr>
+        </p:nvSpPr>
+        <p:spPr/>
+        <p:txBody>
+          <a:bodyPr/>
+          <a:lstStyle/>
+          <a:p>
+            <a:fld id="{11B96697-4585-4368-989A-16003D150648}" type="datetime1">
+              <a:rPr lang="de-CH" noProof="0" smtClean="0"/>
+              <a:t>11.10.2026</a:t>
+            </a:fld>
+            <a:endParaRPr lang="de-CH" noProof="0"/>
+          </a:p>
+        </p:txBody>
+      </p:sp>
+      <p:sp>
+        <p:nvSpPr>
+          <p:cNvPr id="5" name="Footer Placeholder 4">
+            <a:extLst>
+              <a:ext uri="{FF2B5EF4-FFF2-40B4-BE49-F238E27FC236}">
+                <a16:creationId xmlns:a16="http://schemas.microsoft.com/office/drawing/2014/main" id="{545C420F-6705-D6A5-945B-712165C2428C}"/>
+              </a:ext>
+            </a:extLst>
+          </p:cNvPr>
+          <p:cNvSpPr>
+            <a:spLocks noGrp="1"/>
+          </p:cNvSpPr>
+          <p:nvPr>
+            <p:ph type="ftr" sz="quarter" idx="11"/>
+          </p:nvPr>
+        </p:nvSpPr>
+        <p:spPr/>
+        <p:txBody>
+          <a:bodyPr/>
+          <a:lstStyle/>
+          <a:p>
+            <a:r>
+              <a:rPr lang="de-DE"/>
+              <a:t>Department Informatik</a:t>
+            </a:r>
+            <a:endParaRPr lang="de-CH" noProof="0" dirty="0"/>
+          </a:p>
+        </p:txBody>
+      </p:sp>
+      <p:sp>
+        <p:nvSpPr>
+          <p:cNvPr id="6" name="Slide Number Placeholder 5">
+            <a:extLst>
+              <a:ext uri="{FF2B5EF4-FFF2-40B4-BE49-F238E27FC236}">
+                <a16:creationId xmlns:a16="http://schemas.microsoft.com/office/drawing/2014/main" id="{87CD3268-C74E-11D1-B397-6E8B6E7DDFAF}"/>
+              </a:ext>
+            </a:extLst>
+          </p:cNvPr>
+          <p:cNvSpPr>
+            <a:spLocks noGrp="1"/>
+          </p:cNvSpPr>
+          <p:nvPr>
+            <p:ph type="sldNum" sz="quarter" idx="12"/>
+          </p:nvPr>
+        </p:nvSpPr>
+        <p:spPr/>
+        <p:txBody>
+          <a:bodyPr/>
+          <a:lstStyle/>
+          <a:p>
+            <a:fld id="{5ACA52AF-F19D-405C-AD5F-7D94B96A5CC3}" type="slidenum">
+              <a:rPr lang="de-CH" noProof="0" smtClean="0"/>
+              <a:t>7</a:t>
+            </a:fld>
+            <a:endParaRPr lang="de-CH" noProof="0"/>
+          </a:p>
+        </p:txBody>
+      </p:sp>
+    </p:spTree>
+    <p:extLst>
+      <p:ext uri="{BB962C8B-B14F-4D97-AF65-F5344CB8AC3E}">
+        <p14:creationId xmlns:p14="http://schemas.microsoft.com/office/powerpoint/2010/main" val="1087505980"/>
+      </p:ext>
+    </p:extLst>
+  </p:cSld>
+  <p:clrMapOvr>
+    <a:masterClrMapping/>
+  </p:clrMapOvr>
+</p:sld>
+</file>
+
+<file path=ppt/slides/slide8.xml><?xml version="1.0" encoding="utf-8"?>
 <p:sld xmlns:a="http://schemas.openxmlformats.org/drawingml/2006/main" xmlns:r="http://schemas.openxmlformats.org/officeDocument/2006/relationships" xmlns:p="http://schemas.openxmlformats.org/presentationml/2006/main">
   <p:cSld>
     <p:spTree>
@@ -30870,7 +31869,7 @@
           <a:p>
             <a:fld id="{11B96697-4585-4368-989A-16003D150648}" type="datetime1">
               <a:rPr lang="de-CH" noProof="0" smtClean="0"/>
-              <a:t>10.10.2026</a:t>
+              <a:t>11.10.2026</a:t>
             </a:fld>
             <a:endParaRPr lang="de-CH" noProof="0"/>
           </a:p>
@@ -30928,7 +31927,7 @@
           <a:p>
             <a:fld id="{5ACA52AF-F19D-405C-AD5F-7D94B96A5CC3}" type="slidenum">
               <a:rPr lang="de-CH" noProof="0" smtClean="0"/>
-              <a:t>9</a:t>
+              <a:t>8</a:t>
             </a:fld>
             <a:endParaRPr lang="de-CH" noProof="0"/>
           </a:p>
@@ -30968,6 +31967,165 @@
     <p:extLst>
       <p:ext uri="{BB962C8B-B14F-4D97-AF65-F5344CB8AC3E}">
         <p14:creationId xmlns:p14="http://schemas.microsoft.com/office/powerpoint/2010/main" val="863898835"/>
+      </p:ext>
+    </p:extLst>
+  </p:cSld>
+  <p:clrMapOvr>
+    <a:masterClrMapping/>
+  </p:clrMapOvr>
+</p:sld>
+</file>
+
+<file path=ppt/slides/slide9.xml><?xml version="1.0" encoding="utf-8"?>
+<p:sld xmlns:a="http://schemas.openxmlformats.org/drawingml/2006/main" xmlns:r="http://schemas.openxmlformats.org/officeDocument/2006/relationships" xmlns:p="http://schemas.openxmlformats.org/presentationml/2006/main">
+  <p:cSld>
+    <p:spTree>
+      <p:nvGrpSpPr>
+        <p:cNvPr id="1" name=""/>
+        <p:cNvGrpSpPr/>
+        <p:nvPr/>
+      </p:nvGrpSpPr>
+      <p:grpSpPr>
+        <a:xfrm>
+          <a:off x="0" y="0"/>
+          <a:ext cx="0" cy="0"/>
+          <a:chOff x="0" y="0"/>
+          <a:chExt cx="0" cy="0"/>
+        </a:xfrm>
+      </p:grpSpPr>
+      <p:sp>
+        <p:nvSpPr>
+          <p:cNvPr id="2" name="Title 1">
+            <a:extLst>
+              <a:ext uri="{FF2B5EF4-FFF2-40B4-BE49-F238E27FC236}">
+                <a16:creationId xmlns:a16="http://schemas.microsoft.com/office/drawing/2014/main" id="{E441C180-196E-F0AC-C7CD-BFFD16421107}"/>
+              </a:ext>
+            </a:extLst>
+          </p:cNvPr>
+          <p:cNvSpPr>
+            <a:spLocks noGrp="1"/>
+          </p:cNvSpPr>
+          <p:nvPr>
+            <p:ph type="title"/>
+          </p:nvPr>
+        </p:nvSpPr>
+        <p:spPr/>
+        <p:txBody>
+          <a:bodyPr/>
+          <a:lstStyle/>
+          <a:p>
+            <a:r>
+              <a:rPr lang="en-US" dirty="0" err="1"/>
+              <a:t>Stückweise</a:t>
+            </a:r>
+            <a:r>
+              <a:rPr lang="en-US" dirty="0"/>
+              <a:t> </a:t>
+            </a:r>
+            <a:r>
+              <a:rPr lang="en-US" dirty="0" err="1"/>
+              <a:t>Polynomiale</a:t>
+            </a:r>
+            <a:r>
+              <a:rPr lang="en-US" dirty="0"/>
+              <a:t> Interpolation</a:t>
+            </a:r>
+            <a:endParaRPr lang="en-CH" dirty="0"/>
+          </a:p>
+        </p:txBody>
+      </p:sp>
+      <p:sp>
+        <p:nvSpPr>
+          <p:cNvPr id="3" name="Date Placeholder 2">
+            <a:extLst>
+              <a:ext uri="{FF2B5EF4-FFF2-40B4-BE49-F238E27FC236}">
+                <a16:creationId xmlns:a16="http://schemas.microsoft.com/office/drawing/2014/main" id="{CA9B37DA-7967-CCB3-7779-323F6FB7FC38}"/>
+              </a:ext>
+            </a:extLst>
+          </p:cNvPr>
+          <p:cNvSpPr>
+            <a:spLocks noGrp="1"/>
+          </p:cNvSpPr>
+          <p:nvPr>
+            <p:ph type="dt" sz="half" idx="10"/>
+          </p:nvPr>
+        </p:nvSpPr>
+        <p:spPr/>
+        <p:txBody>
+          <a:bodyPr/>
+          <a:lstStyle/>
+          <a:p>
+            <a:fld id="{6C4EAFE7-317E-4912-B75C-DD6945F82242}" type="datetime1">
+              <a:rPr lang="de-CH" noProof="0" smtClean="0"/>
+              <a:t>11.10.2026</a:t>
+            </a:fld>
+            <a:endParaRPr lang="de-CH" noProof="0"/>
+          </a:p>
+        </p:txBody>
+      </p:sp>
+      <p:sp>
+        <p:nvSpPr>
+          <p:cNvPr id="4" name="Footer Placeholder 3">
+            <a:extLst>
+              <a:ext uri="{FF2B5EF4-FFF2-40B4-BE49-F238E27FC236}">
+                <a16:creationId xmlns:a16="http://schemas.microsoft.com/office/drawing/2014/main" id="{B88E9833-4A02-0662-CB34-0EE7A0EC8989}"/>
+              </a:ext>
+            </a:extLst>
+          </p:cNvPr>
+          <p:cNvSpPr>
+            <a:spLocks noGrp="1"/>
+          </p:cNvSpPr>
+          <p:nvPr>
+            <p:ph type="ftr" sz="quarter" idx="11"/>
+          </p:nvPr>
+        </p:nvSpPr>
+        <p:spPr/>
+        <p:txBody>
+          <a:bodyPr/>
+          <a:lstStyle/>
+          <a:p>
+            <a:r>
+              <a:rPr lang="de-DE"/>
+              <a:t>Department Informatik</a:t>
+            </a:r>
+            <a:endParaRPr lang="de-CH" noProof="0" dirty="0"/>
+          </a:p>
+        </p:txBody>
+      </p:sp>
+      <p:sp>
+        <p:nvSpPr>
+          <p:cNvPr id="5" name="Slide Number Placeholder 4">
+            <a:extLst>
+              <a:ext uri="{FF2B5EF4-FFF2-40B4-BE49-F238E27FC236}">
+                <a16:creationId xmlns:a16="http://schemas.microsoft.com/office/drawing/2014/main" id="{0A0529C1-84CB-D744-A582-E2D00B467A2B}"/>
+              </a:ext>
+            </a:extLst>
+          </p:cNvPr>
+          <p:cNvSpPr>
+            <a:spLocks noGrp="1"/>
+          </p:cNvSpPr>
+          <p:nvPr>
+            <p:ph type="sldNum" sz="quarter" idx="12"/>
+          </p:nvPr>
+        </p:nvSpPr>
+        <p:spPr/>
+        <p:txBody>
+          <a:bodyPr/>
+          <a:lstStyle/>
+          <a:p>
+            <a:fld id="{5ACA52AF-F19D-405C-AD5F-7D94B96A5CC3}" type="slidenum">
+              <a:rPr lang="de-CH" noProof="0" smtClean="0"/>
+              <a:pPr/>
+              <a:t>9</a:t>
+            </a:fld>
+            <a:endParaRPr lang="de-CH" noProof="0"/>
+          </a:p>
+        </p:txBody>
+      </p:sp>
+    </p:spTree>
+    <p:extLst>
+      <p:ext uri="{BB962C8B-B14F-4D97-AF65-F5344CB8AC3E}">
+        <p14:creationId xmlns:p14="http://schemas.microsoft.com/office/powerpoint/2010/main" val="1938745952"/>
       </p:ext>
     </p:extLst>
   </p:cSld>

</xml_diff>